<commit_message>
finish unified survey visual validation
</commit_message>
<xml_diff>
--- a/artifacts/active/Figure1_module_timeline_native.pptx
+++ b/artifacts/active/Figure1_module_timeline_native.pptx
@@ -2,13 +2,13 @@
 <file path=ppt/presentation.xml><?xml version="1.0" encoding="utf-8"?>
 <p:presentation xmlns:p="http://schemas.openxmlformats.org/presentationml/2006/main">
   <p:sldMasterIdLst>
-    <p:sldMasterId xmlns:r="http://schemas.openxmlformats.org/officeDocument/2006/relationships" id="2147483648" r:id="R654ea05588a04bef"/>
+    <p:sldMasterId xmlns:r="http://schemas.openxmlformats.org/officeDocument/2006/relationships" id="2147483648" r:id="R17d54ec31bf94275"/>
   </p:sldMasterIdLst>
   <p:notesMasterIdLst>
-    <p:notesMasterId xmlns:r="http://schemas.openxmlformats.org/officeDocument/2006/relationships" r:id="R325660fbab9e43a9"/>
+    <p:notesMasterId xmlns:r="http://schemas.openxmlformats.org/officeDocument/2006/relationships" r:id="Re721fccdf32042d1"/>
   </p:notesMasterIdLst>
   <p:sldIdLst>
-    <p:sldId xmlns:r="http://schemas.openxmlformats.org/officeDocument/2006/relationships" id="256" r:id="R9b269b2235f84491"/>
+    <p:sldId xmlns:r="http://schemas.openxmlformats.org/officeDocument/2006/relationships" id="256" r:id="R2feff3d3f2024013"/>
   </p:sldIdLst>
   <p:sldSz cx="15240000" cy="8572500"/>
   <p:notesSz cx="6858000" cy="9144000"/>
@@ -510,7 +510,7 @@
   </p:cSld>
   <p:clrMap bg1="lt1" tx1="dk1" bg2="lt2" tx2="dk2" accent1="accent1" accent2="accent2" accent3="accent3" accent4="accent4" accent5="accent5" accent6="accent6" hlink="hlink" folHlink="folHlink"/>
   <p:sldLayoutIdLst>
-    <p:sldLayoutId xmlns:r="http://schemas.openxmlformats.org/officeDocument/2006/relationships" id="2147483649" r:id="R3c75e402a55a49fa"/>
+    <p:sldLayoutId xmlns:r="http://schemas.openxmlformats.org/officeDocument/2006/relationships" id="2147483649" r:id="Rc77edd2693ba425d"/>
   </p:sldLayoutIdLst>
   <p:txStyles>
     <p:titleStyle>
@@ -1061,7 +1061,7 @@
           <p:cNvPr id="253" name="figure-title">
             <a:extLst xmlns:a="http://schemas.openxmlformats.org/drawingml/2006/main">
               <a:ext uri="{FF2B5EF4-FFF2-40B4-BE49-F238E27FC236}">
-                <a16:creationId xmlns:a16="http://schemas.microsoft.com/office/drawing/2014/main" id="{9A4520FC-0D3E-46A5-BB53-8C045DE94B87}"/>
+                <a16:creationId xmlns:a16="http://schemas.microsoft.com/office/drawing/2014/main" id="{AAAEDF04-520B-4AE9-9B3A-8FDAF1D22A1E}"/>
               </a:ext>
             </a:extLst>
           </p:cNvPr>
@@ -1117,7 +1117,7 @@
           <p:cNvPr id="2" name="figure-subtitle">
             <a:extLst xmlns:a="http://schemas.openxmlformats.org/drawingml/2006/main">
               <a:ext uri="{FF2B5EF4-FFF2-40B4-BE49-F238E27FC236}">
-                <a16:creationId xmlns:a16="http://schemas.microsoft.com/office/drawing/2014/main" id="{B75866D8-032D-4F14-9617-3AD03E9BBF90}"/>
+                <a16:creationId xmlns:a16="http://schemas.microsoft.com/office/drawing/2014/main" id="{C1F11FFC-E359-48A0-AFC3-D2CB6227873D}"/>
               </a:ext>
             </a:extLst>
           </p:cNvPr>
@@ -1173,7 +1173,7 @@
           <p:cNvPr id="3" name="plot-surface">
             <a:extLst xmlns:a="http://schemas.openxmlformats.org/drawingml/2006/main">
               <a:ext uri="{FF2B5EF4-FFF2-40B4-BE49-F238E27FC236}">
-                <a16:creationId xmlns:a16="http://schemas.microsoft.com/office/drawing/2014/main" id="{E11D590E-B28E-423C-AF97-3AED84279625}"/>
+                <a16:creationId xmlns:a16="http://schemas.microsoft.com/office/drawing/2014/main" id="{8CB0834E-839B-466E-811B-E67944D374E5}"/>
               </a:ext>
             </a:extLst>
           </p:cNvPr>
@@ -1206,7 +1206,7 @@
           <p:cNvPr id="4" name="grid-1">
             <a:extLst xmlns:a="http://schemas.openxmlformats.org/drawingml/2006/main">
               <a:ext uri="{FF2B5EF4-FFF2-40B4-BE49-F238E27FC236}">
-                <a16:creationId xmlns:a16="http://schemas.microsoft.com/office/drawing/2014/main" id="{985922C0-6349-429C-A2BE-1C515836AEA3}"/>
+                <a16:creationId xmlns:a16="http://schemas.microsoft.com/office/drawing/2014/main" id="{12CC6EF9-2145-4571-85C9-66C64010AAEC}"/>
               </a:ext>
             </a:extLst>
           </p:cNvPr>
@@ -1237,7 +1237,7 @@
           <p:cNvPr id="5" name="ytick-1">
             <a:extLst xmlns:a="http://schemas.openxmlformats.org/drawingml/2006/main">
               <a:ext uri="{FF2B5EF4-FFF2-40B4-BE49-F238E27FC236}">
-                <a16:creationId xmlns:a16="http://schemas.microsoft.com/office/drawing/2014/main" id="{66303A70-32CD-43B1-A5BC-5A1562F8BFAA}"/>
+                <a16:creationId xmlns:a16="http://schemas.microsoft.com/office/drawing/2014/main" id="{82A099C2-8E04-4647-B68F-2F73708A803E}"/>
               </a:ext>
             </a:extLst>
           </p:cNvPr>
@@ -1293,7 +1293,7 @@
           <p:cNvPr id="6" name="grid-10">
             <a:extLst xmlns:a="http://schemas.openxmlformats.org/drawingml/2006/main">
               <a:ext uri="{FF2B5EF4-FFF2-40B4-BE49-F238E27FC236}">
-                <a16:creationId xmlns:a16="http://schemas.microsoft.com/office/drawing/2014/main" id="{1ED38728-7856-4018-B8B6-984B447B14E4}"/>
+                <a16:creationId xmlns:a16="http://schemas.microsoft.com/office/drawing/2014/main" id="{F6B5FA7D-2D7A-42FC-A867-F4F70664521A}"/>
               </a:ext>
             </a:extLst>
           </p:cNvPr>
@@ -1324,7 +1324,7 @@
           <p:cNvPr id="7" name="ytick-10">
             <a:extLst xmlns:a="http://schemas.openxmlformats.org/drawingml/2006/main">
               <a:ext uri="{FF2B5EF4-FFF2-40B4-BE49-F238E27FC236}">
-                <a16:creationId xmlns:a16="http://schemas.microsoft.com/office/drawing/2014/main" id="{80C56513-9317-4907-B118-1FD444485A8B}"/>
+                <a16:creationId xmlns:a16="http://schemas.microsoft.com/office/drawing/2014/main" id="{D825F060-62C9-4301-849B-574920783488}"/>
               </a:ext>
             </a:extLst>
           </p:cNvPr>
@@ -1380,7 +1380,7 @@
           <p:cNvPr id="8" name="grid-100">
             <a:extLst xmlns:a="http://schemas.openxmlformats.org/drawingml/2006/main">
               <a:ext uri="{FF2B5EF4-FFF2-40B4-BE49-F238E27FC236}">
-                <a16:creationId xmlns:a16="http://schemas.microsoft.com/office/drawing/2014/main" id="{ECE9C2C7-8BFF-4508-8522-28ADFABA2CED}"/>
+                <a16:creationId xmlns:a16="http://schemas.microsoft.com/office/drawing/2014/main" id="{E89665B4-511F-4EE6-BF55-4A1AD2489E96}"/>
               </a:ext>
             </a:extLst>
           </p:cNvPr>
@@ -1411,7 +1411,7 @@
           <p:cNvPr id="9" name="ytick-100">
             <a:extLst xmlns:a="http://schemas.openxmlformats.org/drawingml/2006/main">
               <a:ext uri="{FF2B5EF4-FFF2-40B4-BE49-F238E27FC236}">
-                <a16:creationId xmlns:a16="http://schemas.microsoft.com/office/drawing/2014/main" id="{11880F83-8F15-4FD8-AFD3-1DC4BD0B2DF8}"/>
+                <a16:creationId xmlns:a16="http://schemas.microsoft.com/office/drawing/2014/main" id="{6B614C57-C574-4B56-8DCF-CFE37C341902}"/>
               </a:ext>
             </a:extLst>
           </p:cNvPr>
@@ -1467,7 +1467,7 @@
           <p:cNvPr id="10" name="grid-300">
             <a:extLst xmlns:a="http://schemas.openxmlformats.org/drawingml/2006/main">
               <a:ext uri="{FF2B5EF4-FFF2-40B4-BE49-F238E27FC236}">
-                <a16:creationId xmlns:a16="http://schemas.microsoft.com/office/drawing/2014/main" id="{3B3428E7-9912-446E-8701-67CB7DCD5CD6}"/>
+                <a16:creationId xmlns:a16="http://schemas.microsoft.com/office/drawing/2014/main" id="{BD4D6DF6-EE6F-49AF-917D-87F81D77CE75}"/>
               </a:ext>
             </a:extLst>
           </p:cNvPr>
@@ -1498,7 +1498,7 @@
           <p:cNvPr id="11" name="ytick-300">
             <a:extLst xmlns:a="http://schemas.openxmlformats.org/drawingml/2006/main">
               <a:ext uri="{FF2B5EF4-FFF2-40B4-BE49-F238E27FC236}">
-                <a16:creationId xmlns:a16="http://schemas.microsoft.com/office/drawing/2014/main" id="{B58B385E-C493-47EA-A4D8-1A6C32E3492B}"/>
+                <a16:creationId xmlns:a16="http://schemas.microsoft.com/office/drawing/2014/main" id="{D6CCBBAD-6B4B-4F27-A77B-1841FBA9ADCA}"/>
               </a:ext>
             </a:extLst>
           </p:cNvPr>
@@ -1554,7 +1554,7 @@
           <p:cNvPr id="12" name="x-axis">
             <a:extLst xmlns:a="http://schemas.openxmlformats.org/drawingml/2006/main">
               <a:ext uri="{FF2B5EF4-FFF2-40B4-BE49-F238E27FC236}">
-                <a16:creationId xmlns:a16="http://schemas.microsoft.com/office/drawing/2014/main" id="{68D1095E-731E-43C6-8522-8BC845D27EB6}"/>
+                <a16:creationId xmlns:a16="http://schemas.microsoft.com/office/drawing/2014/main" id="{E57AA7EC-B59F-4709-AAFD-59729D590A79}"/>
               </a:ext>
             </a:extLst>
           </p:cNvPr>
@@ -1585,7 +1585,7 @@
           <p:cNvPr id="13" name="y-axis">
             <a:extLst xmlns:a="http://schemas.openxmlformats.org/drawingml/2006/main">
               <a:ext uri="{FF2B5EF4-FFF2-40B4-BE49-F238E27FC236}">
-                <a16:creationId xmlns:a16="http://schemas.microsoft.com/office/drawing/2014/main" id="{E7535263-59B1-4ED7-830E-8241517FF157}"/>
+                <a16:creationId xmlns:a16="http://schemas.microsoft.com/office/drawing/2014/main" id="{4535F4ED-A668-435B-AE94-584A90820B9B}"/>
               </a:ext>
             </a:extLst>
           </p:cNvPr>
@@ -1616,7 +1616,7 @@
           <p:cNvPr id="14" name="y-axis-title">
             <a:extLst xmlns:a="http://schemas.openxmlformats.org/drawingml/2006/main">
               <a:ext uri="{FF2B5EF4-FFF2-40B4-BE49-F238E27FC236}">
-                <a16:creationId xmlns:a16="http://schemas.microsoft.com/office/drawing/2014/main" id="{37F3628B-39C9-42F3-BB64-4168F94F719D}"/>
+                <a16:creationId xmlns:a16="http://schemas.microsoft.com/office/drawing/2014/main" id="{5B46398E-A975-44F4-89B3-DD4AC1959890}"/>
               </a:ext>
             </a:extLst>
           </p:cNvPr>
@@ -1672,18 +1672,18 @@
           <p:cNvPr id="15" name="x-axis-title">
             <a:extLst xmlns:a="http://schemas.openxmlformats.org/drawingml/2006/main">
               <a:ext uri="{FF2B5EF4-FFF2-40B4-BE49-F238E27FC236}">
-                <a16:creationId xmlns:a16="http://schemas.microsoft.com/office/drawing/2014/main" id="{F22B7F9C-0FB4-4B1A-AD00-3367105B2FB4}"/>
-              </a:ext>
-            </a:extLst>
-          </p:cNvPr>
-          <p:cNvSpPr>
-            <a:spLocks xmlns:a="http://schemas.openxmlformats.org/drawingml/2006/main" noGrp="1"/>
-          </p:cNvSpPr>
-          <p:nvPr/>
-        </p:nvSpPr>
-        <p:spPr>
-          <a:xfrm xmlns:a="http://schemas.openxmlformats.org/drawingml/2006/main">
-            <a:off x="6572250" y="7162800"/>
+                <a16:creationId xmlns:a16="http://schemas.microsoft.com/office/drawing/2014/main" id="{F83D0065-36A0-47F2-8615-02BDF93E4468}"/>
+              </a:ext>
+            </a:extLst>
+          </p:cNvPr>
+          <p:cNvSpPr>
+            <a:spLocks xmlns:a="http://schemas.openxmlformats.org/drawingml/2006/main" noGrp="1"/>
+          </p:cNvSpPr>
+          <p:nvPr/>
+        </p:nvSpPr>
+        <p:spPr>
+          <a:xfrm xmlns:a="http://schemas.openxmlformats.org/drawingml/2006/main">
+            <a:off x="6572250" y="7391400"/>
             <a:ext cx="2381250" cy="228600"/>
           </a:xfrm>
           <a:prstGeom xmlns:a="http://schemas.openxmlformats.org/drawingml/2006/main" prst="rect">
@@ -1728,7 +1728,7 @@
           <p:cNvPr id="16" name="xtick-0">
             <a:extLst xmlns:a="http://schemas.openxmlformats.org/drawingml/2006/main">
               <a:ext uri="{FF2B5EF4-FFF2-40B4-BE49-F238E27FC236}">
-                <a16:creationId xmlns:a16="http://schemas.microsoft.com/office/drawing/2014/main" id="{084C0F16-F07D-499F-BFDB-EC5C50CA2C6B}"/>
+                <a16:creationId xmlns:a16="http://schemas.microsoft.com/office/drawing/2014/main" id="{EA34D682-2EBD-4FEB-96A1-29D668D7CD47}"/>
               </a:ext>
             </a:extLst>
           </p:cNvPr>
@@ -1759,7 +1759,7 @@
           <p:cNvPr id="17" name="xlabel-0">
             <a:extLst xmlns:a="http://schemas.openxmlformats.org/drawingml/2006/main">
               <a:ext uri="{FF2B5EF4-FFF2-40B4-BE49-F238E27FC236}">
-                <a16:creationId xmlns:a16="http://schemas.microsoft.com/office/drawing/2014/main" id="{9537D43A-9404-48BC-879D-53871282CE28}"/>
+                <a16:creationId xmlns:a16="http://schemas.microsoft.com/office/drawing/2014/main" id="{43640669-2660-4A86-86DD-0CF5D1F2B767}"/>
               </a:ext>
             </a:extLst>
           </p:cNvPr>
@@ -1815,7 +1815,7 @@
           <p:cNvPr id="18" name="xtick-5">
             <a:extLst xmlns:a="http://schemas.openxmlformats.org/drawingml/2006/main">
               <a:ext uri="{FF2B5EF4-FFF2-40B4-BE49-F238E27FC236}">
-                <a16:creationId xmlns:a16="http://schemas.microsoft.com/office/drawing/2014/main" id="{8E0E69CC-8AEE-424E-BC83-4F5B51AB1EEF}"/>
+                <a16:creationId xmlns:a16="http://schemas.microsoft.com/office/drawing/2014/main" id="{DC573673-F78E-4B61-AFD6-8DDF12C46E37}"/>
               </a:ext>
             </a:extLst>
           </p:cNvPr>
@@ -1846,7 +1846,7 @@
           <p:cNvPr id="19" name="xlabel-5">
             <a:extLst xmlns:a="http://schemas.openxmlformats.org/drawingml/2006/main">
               <a:ext uri="{FF2B5EF4-FFF2-40B4-BE49-F238E27FC236}">
-                <a16:creationId xmlns:a16="http://schemas.microsoft.com/office/drawing/2014/main" id="{A839F9CD-3499-409D-A5C2-8E0DCA1FCD17}"/>
+                <a16:creationId xmlns:a16="http://schemas.microsoft.com/office/drawing/2014/main" id="{F06A6946-FF61-496E-B5C1-E591A50C8776}"/>
               </a:ext>
             </a:extLst>
           </p:cNvPr>
@@ -1902,7 +1902,7 @@
           <p:cNvPr id="20" name="xtick-10">
             <a:extLst xmlns:a="http://schemas.openxmlformats.org/drawingml/2006/main">
               <a:ext uri="{FF2B5EF4-FFF2-40B4-BE49-F238E27FC236}">
-                <a16:creationId xmlns:a16="http://schemas.microsoft.com/office/drawing/2014/main" id="{D6E23AD8-33AB-4118-BF60-EB71E77D4071}"/>
+                <a16:creationId xmlns:a16="http://schemas.microsoft.com/office/drawing/2014/main" id="{DC051957-675F-4351-BEAD-754904176EC3}"/>
               </a:ext>
             </a:extLst>
           </p:cNvPr>
@@ -1933,7 +1933,7 @@
           <p:cNvPr id="21" name="xlabel-10">
             <a:extLst xmlns:a="http://schemas.openxmlformats.org/drawingml/2006/main">
               <a:ext uri="{FF2B5EF4-FFF2-40B4-BE49-F238E27FC236}">
-                <a16:creationId xmlns:a16="http://schemas.microsoft.com/office/drawing/2014/main" id="{03A60B5E-72EA-4491-83E8-056AADCBD818}"/>
+                <a16:creationId xmlns:a16="http://schemas.microsoft.com/office/drawing/2014/main" id="{988A4722-D9CA-4884-9741-A8D95F135879}"/>
               </a:ext>
             </a:extLst>
           </p:cNvPr>
@@ -1989,7 +1989,7 @@
           <p:cNvPr id="22" name="xtick-15">
             <a:extLst xmlns:a="http://schemas.openxmlformats.org/drawingml/2006/main">
               <a:ext uri="{FF2B5EF4-FFF2-40B4-BE49-F238E27FC236}">
-                <a16:creationId xmlns:a16="http://schemas.microsoft.com/office/drawing/2014/main" id="{A9B6E95C-65D1-4EDA-A742-0DF327B01589}"/>
+                <a16:creationId xmlns:a16="http://schemas.microsoft.com/office/drawing/2014/main" id="{2367758D-F6CC-4BD8-BE69-31A4875BB7AF}"/>
               </a:ext>
             </a:extLst>
           </p:cNvPr>
@@ -2020,7 +2020,7 @@
           <p:cNvPr id="23" name="xlabel-15">
             <a:extLst xmlns:a="http://schemas.openxmlformats.org/drawingml/2006/main">
               <a:ext uri="{FF2B5EF4-FFF2-40B4-BE49-F238E27FC236}">
-                <a16:creationId xmlns:a16="http://schemas.microsoft.com/office/drawing/2014/main" id="{F0F87713-C2CC-46A6-978D-6615EDF828E3}"/>
+                <a16:creationId xmlns:a16="http://schemas.microsoft.com/office/drawing/2014/main" id="{472D66A1-85DE-4D96-A1D6-8E55F071ACBD}"/>
               </a:ext>
             </a:extLst>
           </p:cNvPr>
@@ -2076,7 +2076,7 @@
           <p:cNvPr id="24" name="xtick-20">
             <a:extLst xmlns:a="http://schemas.openxmlformats.org/drawingml/2006/main">
               <a:ext uri="{FF2B5EF4-FFF2-40B4-BE49-F238E27FC236}">
-                <a16:creationId xmlns:a16="http://schemas.microsoft.com/office/drawing/2014/main" id="{79D030A3-C2A5-4D83-AE30-BDD0AE068081}"/>
+                <a16:creationId xmlns:a16="http://schemas.microsoft.com/office/drawing/2014/main" id="{E3A6D0AE-5C2E-434E-B1EB-6ACE1546264C}"/>
               </a:ext>
             </a:extLst>
           </p:cNvPr>
@@ -2107,7 +2107,7 @@
           <p:cNvPr id="25" name="xlabel-20">
             <a:extLst xmlns:a="http://schemas.openxmlformats.org/drawingml/2006/main">
               <a:ext uri="{FF2B5EF4-FFF2-40B4-BE49-F238E27FC236}">
-                <a16:creationId xmlns:a16="http://schemas.microsoft.com/office/drawing/2014/main" id="{9A2824A0-3340-4E4A-823C-88B8EBB84414}"/>
+                <a16:creationId xmlns:a16="http://schemas.microsoft.com/office/drawing/2014/main" id="{7986F5D8-FE9B-480E-9A30-2C3936E637EA}"/>
               </a:ext>
             </a:extLst>
           </p:cNvPr>
@@ -2163,7 +2163,7 @@
           <p:cNvPr id="26" name="xtick-29">
             <a:extLst xmlns:a="http://schemas.openxmlformats.org/drawingml/2006/main">
               <a:ext uri="{FF2B5EF4-FFF2-40B4-BE49-F238E27FC236}">
-                <a16:creationId xmlns:a16="http://schemas.microsoft.com/office/drawing/2014/main" id="{4A55EBE5-AE59-402B-A672-99C1C057996D}"/>
+                <a16:creationId xmlns:a16="http://schemas.microsoft.com/office/drawing/2014/main" id="{267E526C-2A99-49FE-A29D-C8B429BF6296}"/>
               </a:ext>
             </a:extLst>
           </p:cNvPr>
@@ -2194,7 +2194,7 @@
           <p:cNvPr id="27" name="xlabel-29">
             <a:extLst xmlns:a="http://schemas.openxmlformats.org/drawingml/2006/main">
               <a:ext uri="{FF2B5EF4-FFF2-40B4-BE49-F238E27FC236}">
-                <a16:creationId xmlns:a16="http://schemas.microsoft.com/office/drawing/2014/main" id="{ED21F95F-8324-4620-ACD5-F8FBA331D058}"/>
+                <a16:creationId xmlns:a16="http://schemas.microsoft.com/office/drawing/2014/main" id="{1BA68846-D4F3-4AC9-A7E7-DEF46A8D00E4}"/>
               </a:ext>
             </a:extLst>
           </p:cNvPr>
@@ -2250,7 +2250,7 @@
           <p:cNvPr id="28" name="LLM-side-segment-1">
             <a:extLst xmlns:a="http://schemas.openxmlformats.org/drawingml/2006/main">
               <a:ext uri="{FF2B5EF4-FFF2-40B4-BE49-F238E27FC236}">
-                <a16:creationId xmlns:a16="http://schemas.microsoft.com/office/drawing/2014/main" id="{0E0E1A77-BFAD-433D-B10B-D123205C2459}"/>
+                <a16:creationId xmlns:a16="http://schemas.microsoft.com/office/drawing/2014/main" id="{187A37CE-617E-4871-909F-DFDDB4BECDE3}"/>
               </a:ext>
             </a:extLst>
           </p:cNvPr>
@@ -2281,7 +2281,7 @@
           <p:cNvPr id="29" name="LLM-side-segment-2">
             <a:extLst xmlns:a="http://schemas.openxmlformats.org/drawingml/2006/main">
               <a:ext uri="{FF2B5EF4-FFF2-40B4-BE49-F238E27FC236}">
-                <a16:creationId xmlns:a16="http://schemas.microsoft.com/office/drawing/2014/main" id="{B04AD69B-47FF-4B46-B8BA-110E48888321}"/>
+                <a16:creationId xmlns:a16="http://schemas.microsoft.com/office/drawing/2014/main" id="{EF8FDB7B-486A-4DF0-AF2E-8AEC27299EB2}"/>
               </a:ext>
             </a:extLst>
           </p:cNvPr>
@@ -2312,7 +2312,7 @@
           <p:cNvPr id="30" name="LLM-side-segment-3">
             <a:extLst xmlns:a="http://schemas.openxmlformats.org/drawingml/2006/main">
               <a:ext uri="{FF2B5EF4-FFF2-40B4-BE49-F238E27FC236}">
-                <a16:creationId xmlns:a16="http://schemas.microsoft.com/office/drawing/2014/main" id="{17795769-EE80-44CC-B296-D600003F0C2C}"/>
+                <a16:creationId xmlns:a16="http://schemas.microsoft.com/office/drawing/2014/main" id="{74748722-D76D-4558-BA28-6B9927497351}"/>
               </a:ext>
             </a:extLst>
           </p:cNvPr>
@@ -2343,7 +2343,7 @@
           <p:cNvPr id="31" name="LLM-side-segment-4">
             <a:extLst xmlns:a="http://schemas.openxmlformats.org/drawingml/2006/main">
               <a:ext uri="{FF2B5EF4-FFF2-40B4-BE49-F238E27FC236}">
-                <a16:creationId xmlns:a16="http://schemas.microsoft.com/office/drawing/2014/main" id="{903E3A1B-58D2-47CF-A8C3-EC4D3316CB84}"/>
+                <a16:creationId xmlns:a16="http://schemas.microsoft.com/office/drawing/2014/main" id="{4251526C-D2BD-4F4F-A9A2-7A4BF23C41BD}"/>
               </a:ext>
             </a:extLst>
           </p:cNvPr>
@@ -2374,7 +2374,7 @@
           <p:cNvPr id="32" name="LLM-side-segment-5">
             <a:extLst xmlns:a="http://schemas.openxmlformats.org/drawingml/2006/main">
               <a:ext uri="{FF2B5EF4-FFF2-40B4-BE49-F238E27FC236}">
-                <a16:creationId xmlns:a16="http://schemas.microsoft.com/office/drawing/2014/main" id="{F56B7143-1E94-4785-BF64-7CABDD0113DA}"/>
+                <a16:creationId xmlns:a16="http://schemas.microsoft.com/office/drawing/2014/main" id="{F75B7501-C348-4F0C-9CEC-E81BE2985621}"/>
               </a:ext>
             </a:extLst>
           </p:cNvPr>
@@ -2405,7 +2405,7 @@
           <p:cNvPr id="33" name="LLM-side-segment-6">
             <a:extLst xmlns:a="http://schemas.openxmlformats.org/drawingml/2006/main">
               <a:ext uri="{FF2B5EF4-FFF2-40B4-BE49-F238E27FC236}">
-                <a16:creationId xmlns:a16="http://schemas.microsoft.com/office/drawing/2014/main" id="{84CCEC9B-C63B-4DC0-9E90-B5F4DB105BA5}"/>
+                <a16:creationId xmlns:a16="http://schemas.microsoft.com/office/drawing/2014/main" id="{8D6F87C4-C073-4B89-89BE-54FC09203436}"/>
               </a:ext>
             </a:extLst>
           </p:cNvPr>
@@ -2436,7 +2436,7 @@
           <p:cNvPr id="34" name="LLM-side-segment-7">
             <a:extLst xmlns:a="http://schemas.openxmlformats.org/drawingml/2006/main">
               <a:ext uri="{FF2B5EF4-FFF2-40B4-BE49-F238E27FC236}">
-                <a16:creationId xmlns:a16="http://schemas.microsoft.com/office/drawing/2014/main" id="{35D8C17A-1C1D-42BA-8169-9FC52B761EE2}"/>
+                <a16:creationId xmlns:a16="http://schemas.microsoft.com/office/drawing/2014/main" id="{40B7DF25-621F-41F2-9CC7-548A267B5C89}"/>
               </a:ext>
             </a:extLst>
           </p:cNvPr>
@@ -2467,7 +2467,7 @@
           <p:cNvPr id="35" name="LLM-side-segment-8">
             <a:extLst xmlns:a="http://schemas.openxmlformats.org/drawingml/2006/main">
               <a:ext uri="{FF2B5EF4-FFF2-40B4-BE49-F238E27FC236}">
-                <a16:creationId xmlns:a16="http://schemas.microsoft.com/office/drawing/2014/main" id="{64F8AAA2-A3CE-4300-89F4-E82861E86DEC}"/>
+                <a16:creationId xmlns:a16="http://schemas.microsoft.com/office/drawing/2014/main" id="{6F8A1E06-2C60-4BD5-9720-8C8534C08990}"/>
               </a:ext>
             </a:extLst>
           </p:cNvPr>
@@ -2498,7 +2498,7 @@
           <p:cNvPr id="36" name="LLM-side-segment-9">
             <a:extLst xmlns:a="http://schemas.openxmlformats.org/drawingml/2006/main">
               <a:ext uri="{FF2B5EF4-FFF2-40B4-BE49-F238E27FC236}">
-                <a16:creationId xmlns:a16="http://schemas.microsoft.com/office/drawing/2014/main" id="{65E7C918-CD5D-4F73-8AF4-F1663F7879D6}"/>
+                <a16:creationId xmlns:a16="http://schemas.microsoft.com/office/drawing/2014/main" id="{0E9C4598-F3D7-43C7-82A5-46C8C249C065}"/>
               </a:ext>
             </a:extLst>
           </p:cNvPr>
@@ -2529,7 +2529,7 @@
           <p:cNvPr id="37" name="LLM-side-segment-10">
             <a:extLst xmlns:a="http://schemas.openxmlformats.org/drawingml/2006/main">
               <a:ext uri="{FF2B5EF4-FFF2-40B4-BE49-F238E27FC236}">
-                <a16:creationId xmlns:a16="http://schemas.microsoft.com/office/drawing/2014/main" id="{CF8E22C7-A512-42BF-8A7F-226494DD194B}"/>
+                <a16:creationId xmlns:a16="http://schemas.microsoft.com/office/drawing/2014/main" id="{548E92C1-EBAC-46F9-A1BB-0A0C9FB09684}"/>
               </a:ext>
             </a:extLst>
           </p:cNvPr>
@@ -2560,7 +2560,7 @@
           <p:cNvPr id="38" name="LLM-side-segment-11">
             <a:extLst xmlns:a="http://schemas.openxmlformats.org/drawingml/2006/main">
               <a:ext uri="{FF2B5EF4-FFF2-40B4-BE49-F238E27FC236}">
-                <a16:creationId xmlns:a16="http://schemas.microsoft.com/office/drawing/2014/main" id="{11E94BC0-60AB-489D-878C-73A12F9C489E}"/>
+                <a16:creationId xmlns:a16="http://schemas.microsoft.com/office/drawing/2014/main" id="{6EF50B79-0040-4B4D-902B-E6778A222D8A}"/>
               </a:ext>
             </a:extLst>
           </p:cNvPr>
@@ -2591,7 +2591,7 @@
           <p:cNvPr id="39" name="LLM-side-segment-12">
             <a:extLst xmlns:a="http://schemas.openxmlformats.org/drawingml/2006/main">
               <a:ext uri="{FF2B5EF4-FFF2-40B4-BE49-F238E27FC236}">
-                <a16:creationId xmlns:a16="http://schemas.microsoft.com/office/drawing/2014/main" id="{ABE80AA3-E521-4F12-9238-7325423E2B52}"/>
+                <a16:creationId xmlns:a16="http://schemas.microsoft.com/office/drawing/2014/main" id="{C106354A-C8F3-468A-A78F-8E54CAD69FBF}"/>
               </a:ext>
             </a:extLst>
           </p:cNvPr>
@@ -2622,7 +2622,7 @@
           <p:cNvPr id="40" name="LLM-side-segment-13">
             <a:extLst xmlns:a="http://schemas.openxmlformats.org/drawingml/2006/main">
               <a:ext uri="{FF2B5EF4-FFF2-40B4-BE49-F238E27FC236}">
-                <a16:creationId xmlns:a16="http://schemas.microsoft.com/office/drawing/2014/main" id="{0BE00437-4F17-4092-9FAB-06A54CE94E8A}"/>
+                <a16:creationId xmlns:a16="http://schemas.microsoft.com/office/drawing/2014/main" id="{5BE6DB00-7621-44A3-8699-6C39959CB673}"/>
               </a:ext>
             </a:extLst>
           </p:cNvPr>
@@ -2653,7 +2653,7 @@
           <p:cNvPr id="41" name="LLM-side-segment-14">
             <a:extLst xmlns:a="http://schemas.openxmlformats.org/drawingml/2006/main">
               <a:ext uri="{FF2B5EF4-FFF2-40B4-BE49-F238E27FC236}">
-                <a16:creationId xmlns:a16="http://schemas.microsoft.com/office/drawing/2014/main" id="{4E0DF5AF-7192-4C0F-AFA6-49C5DFA870AD}"/>
+                <a16:creationId xmlns:a16="http://schemas.microsoft.com/office/drawing/2014/main" id="{35A4B67B-775E-4F6E-8F9C-EC7B00089D73}"/>
               </a:ext>
             </a:extLst>
           </p:cNvPr>
@@ -2684,7 +2684,7 @@
           <p:cNvPr id="42" name="LLM-side-segment-15">
             <a:extLst xmlns:a="http://schemas.openxmlformats.org/drawingml/2006/main">
               <a:ext uri="{FF2B5EF4-FFF2-40B4-BE49-F238E27FC236}">
-                <a16:creationId xmlns:a16="http://schemas.microsoft.com/office/drawing/2014/main" id="{AB4F3FCD-008E-488C-89FD-A72190A1206A}"/>
+                <a16:creationId xmlns:a16="http://schemas.microsoft.com/office/drawing/2014/main" id="{B9A82F46-8D03-4D56-8270-C2B3BF153052}"/>
               </a:ext>
             </a:extLst>
           </p:cNvPr>
@@ -2715,7 +2715,7 @@
           <p:cNvPr id="43" name="LLM-side-segment-16">
             <a:extLst xmlns:a="http://schemas.openxmlformats.org/drawingml/2006/main">
               <a:ext uri="{FF2B5EF4-FFF2-40B4-BE49-F238E27FC236}">
-                <a16:creationId xmlns:a16="http://schemas.microsoft.com/office/drawing/2014/main" id="{70F77B5A-19D4-461D-A2D0-8D701845CD28}"/>
+                <a16:creationId xmlns:a16="http://schemas.microsoft.com/office/drawing/2014/main" id="{E1367E80-A687-49D5-A6E2-A23A626B694C}"/>
               </a:ext>
             </a:extLst>
           </p:cNvPr>
@@ -2746,7 +2746,7 @@
           <p:cNvPr id="44" name="LLM-side-segment-17">
             <a:extLst xmlns:a="http://schemas.openxmlformats.org/drawingml/2006/main">
               <a:ext uri="{FF2B5EF4-FFF2-40B4-BE49-F238E27FC236}">
-                <a16:creationId xmlns:a16="http://schemas.microsoft.com/office/drawing/2014/main" id="{F8108A03-108F-479B-A6DA-F3A647774DF2}"/>
+                <a16:creationId xmlns:a16="http://schemas.microsoft.com/office/drawing/2014/main" id="{D528B47A-3028-4568-9BCB-65CD9686B5BE}"/>
               </a:ext>
             </a:extLst>
           </p:cNvPr>
@@ -2777,7 +2777,7 @@
           <p:cNvPr id="45" name="LLM-side-segment-18">
             <a:extLst xmlns:a="http://schemas.openxmlformats.org/drawingml/2006/main">
               <a:ext uri="{FF2B5EF4-FFF2-40B4-BE49-F238E27FC236}">
-                <a16:creationId xmlns:a16="http://schemas.microsoft.com/office/drawing/2014/main" id="{3744E16B-CCB6-4AC6-9DD3-59CF7ED509B3}"/>
+                <a16:creationId xmlns:a16="http://schemas.microsoft.com/office/drawing/2014/main" id="{11199056-7751-4D59-9CD3-8058CD0A00CB}"/>
               </a:ext>
             </a:extLst>
           </p:cNvPr>
@@ -2808,7 +2808,7 @@
           <p:cNvPr id="46" name="LLM-side-segment-19">
             <a:extLst xmlns:a="http://schemas.openxmlformats.org/drawingml/2006/main">
               <a:ext uri="{FF2B5EF4-FFF2-40B4-BE49-F238E27FC236}">
-                <a16:creationId xmlns:a16="http://schemas.microsoft.com/office/drawing/2014/main" id="{EE5675D1-9E51-46F7-8852-02D23291DD0B}"/>
+                <a16:creationId xmlns:a16="http://schemas.microsoft.com/office/drawing/2014/main" id="{BC19D08C-C1D2-4E7A-BF1E-8266324F9D4D}"/>
               </a:ext>
             </a:extLst>
           </p:cNvPr>
@@ -2839,7 +2839,7 @@
           <p:cNvPr id="47" name="LLM-side-segment-20">
             <a:extLst xmlns:a="http://schemas.openxmlformats.org/drawingml/2006/main">
               <a:ext uri="{FF2B5EF4-FFF2-40B4-BE49-F238E27FC236}">
-                <a16:creationId xmlns:a16="http://schemas.microsoft.com/office/drawing/2014/main" id="{20EADF4D-9CF8-483B-BB0D-8F32B7485D37}"/>
+                <a16:creationId xmlns:a16="http://schemas.microsoft.com/office/drawing/2014/main" id="{6B54BF83-DFFB-4E63-A9D1-52B218576B52}"/>
               </a:ext>
             </a:extLst>
           </p:cNvPr>
@@ -2870,7 +2870,7 @@
           <p:cNvPr id="48" name="LLM-side-segment-21">
             <a:extLst xmlns:a="http://schemas.openxmlformats.org/drawingml/2006/main">
               <a:ext uri="{FF2B5EF4-FFF2-40B4-BE49-F238E27FC236}">
-                <a16:creationId xmlns:a16="http://schemas.microsoft.com/office/drawing/2014/main" id="{BBA6A05C-0027-4D31-8B21-7BA73868FEAE}"/>
+                <a16:creationId xmlns:a16="http://schemas.microsoft.com/office/drawing/2014/main" id="{8718429F-8F9C-4940-B3F9-EFCB7AA0B8F1}"/>
               </a:ext>
             </a:extLst>
           </p:cNvPr>
@@ -2901,7 +2901,7 @@
           <p:cNvPr id="49" name="LLM-side-segment-22">
             <a:extLst xmlns:a="http://schemas.openxmlformats.org/drawingml/2006/main">
               <a:ext uri="{FF2B5EF4-FFF2-40B4-BE49-F238E27FC236}">
-                <a16:creationId xmlns:a16="http://schemas.microsoft.com/office/drawing/2014/main" id="{3948AC22-D0F4-4CE8-BD44-57B3DE935574}"/>
+                <a16:creationId xmlns:a16="http://schemas.microsoft.com/office/drawing/2014/main" id="{FF307C53-32C0-4854-82D0-5C25F2134CE6}"/>
               </a:ext>
             </a:extLst>
           </p:cNvPr>
@@ -2932,7 +2932,7 @@
           <p:cNvPr id="50" name="LLM-side-segment-23">
             <a:extLst xmlns:a="http://schemas.openxmlformats.org/drawingml/2006/main">
               <a:ext uri="{FF2B5EF4-FFF2-40B4-BE49-F238E27FC236}">
-                <a16:creationId xmlns:a16="http://schemas.microsoft.com/office/drawing/2014/main" id="{C7C2AFDA-1D4D-4FF1-A213-7DCB2DD138A2}"/>
+                <a16:creationId xmlns:a16="http://schemas.microsoft.com/office/drawing/2014/main" id="{A0440C79-7797-40FD-8A9B-434B84D105FB}"/>
               </a:ext>
             </a:extLst>
           </p:cNvPr>
@@ -2963,7 +2963,7 @@
           <p:cNvPr id="51" name="LLM-side-segment-24">
             <a:extLst xmlns:a="http://schemas.openxmlformats.org/drawingml/2006/main">
               <a:ext uri="{FF2B5EF4-FFF2-40B4-BE49-F238E27FC236}">
-                <a16:creationId xmlns:a16="http://schemas.microsoft.com/office/drawing/2014/main" id="{EEEDF2FD-DCC3-4B4D-BBCC-E03B68935926}"/>
+                <a16:creationId xmlns:a16="http://schemas.microsoft.com/office/drawing/2014/main" id="{25A8F8F0-5976-41C0-8492-B75783FE2ED9}"/>
               </a:ext>
             </a:extLst>
           </p:cNvPr>
@@ -2994,7 +2994,7 @@
           <p:cNvPr id="52" name="LLM-side-segment-25">
             <a:extLst xmlns:a="http://schemas.openxmlformats.org/drawingml/2006/main">
               <a:ext uri="{FF2B5EF4-FFF2-40B4-BE49-F238E27FC236}">
-                <a16:creationId xmlns:a16="http://schemas.microsoft.com/office/drawing/2014/main" id="{9467BE2B-F8C8-48D7-96B2-8CB4E5EAB0F0}"/>
+                <a16:creationId xmlns:a16="http://schemas.microsoft.com/office/drawing/2014/main" id="{E995D5FF-7A3B-4C7E-A6A0-8CC77F120F3D}"/>
               </a:ext>
             </a:extLst>
           </p:cNvPr>
@@ -3025,7 +3025,7 @@
           <p:cNvPr id="53" name="LLM-side-segment-26">
             <a:extLst xmlns:a="http://schemas.openxmlformats.org/drawingml/2006/main">
               <a:ext uri="{FF2B5EF4-FFF2-40B4-BE49-F238E27FC236}">
-                <a16:creationId xmlns:a16="http://schemas.microsoft.com/office/drawing/2014/main" id="{8931C488-EFCA-49FA-B74E-599B9B58159A}"/>
+                <a16:creationId xmlns:a16="http://schemas.microsoft.com/office/drawing/2014/main" id="{6995FB54-7E12-4502-A993-F5F0167D156F}"/>
               </a:ext>
             </a:extLst>
           </p:cNvPr>
@@ -3056,7 +3056,7 @@
           <p:cNvPr id="54" name="LLM-side-segment-27">
             <a:extLst xmlns:a="http://schemas.openxmlformats.org/drawingml/2006/main">
               <a:ext uri="{FF2B5EF4-FFF2-40B4-BE49-F238E27FC236}">
-                <a16:creationId xmlns:a16="http://schemas.microsoft.com/office/drawing/2014/main" id="{C962CC0C-50C1-467C-A62E-3A40A2DAA55F}"/>
+                <a16:creationId xmlns:a16="http://schemas.microsoft.com/office/drawing/2014/main" id="{F8FD6D71-DE85-4D6F-8328-7070B444C161}"/>
               </a:ext>
             </a:extLst>
           </p:cNvPr>
@@ -3087,7 +3087,7 @@
           <p:cNvPr id="55" name="LLM-side-segment-28">
             <a:extLst xmlns:a="http://schemas.openxmlformats.org/drawingml/2006/main">
               <a:ext uri="{FF2B5EF4-FFF2-40B4-BE49-F238E27FC236}">
-                <a16:creationId xmlns:a16="http://schemas.microsoft.com/office/drawing/2014/main" id="{F4FDB490-FB06-4D76-A1F8-1DCEAA6D156B}"/>
+                <a16:creationId xmlns:a16="http://schemas.microsoft.com/office/drawing/2014/main" id="{45C86DBA-3A23-48DC-9005-E89D477A91B5}"/>
               </a:ext>
             </a:extLst>
           </p:cNvPr>
@@ -3118,7 +3118,7 @@
           <p:cNvPr id="56" name="LLM-side-segment-29">
             <a:extLst xmlns:a="http://schemas.openxmlformats.org/drawingml/2006/main">
               <a:ext uri="{FF2B5EF4-FFF2-40B4-BE49-F238E27FC236}">
-                <a16:creationId xmlns:a16="http://schemas.microsoft.com/office/drawing/2014/main" id="{99E48C71-C950-4147-B593-94397A22A265}"/>
+                <a16:creationId xmlns:a16="http://schemas.microsoft.com/office/drawing/2014/main" id="{1EE525DA-0832-4488-B504-35DCE31419BB}"/>
               </a:ext>
             </a:extLst>
           </p:cNvPr>
@@ -3149,7 +3149,7 @@
           <p:cNvPr id="57" name="LLM-side-marker-0">
             <a:extLst xmlns:a="http://schemas.openxmlformats.org/drawingml/2006/main">
               <a:ext uri="{FF2B5EF4-FFF2-40B4-BE49-F238E27FC236}">
-                <a16:creationId xmlns:a16="http://schemas.microsoft.com/office/drawing/2014/main" id="{EF20D28C-8461-4B3E-A558-8C221E2DAC0D}"/>
+                <a16:creationId xmlns:a16="http://schemas.microsoft.com/office/drawing/2014/main" id="{B3DA11DC-91D6-46B9-9913-E4E9DAA37905}"/>
               </a:ext>
             </a:extLst>
           </p:cNvPr>
@@ -3182,7 +3182,7 @@
           <p:cNvPr id="58" name="LLM-side-marker-1">
             <a:extLst xmlns:a="http://schemas.openxmlformats.org/drawingml/2006/main">
               <a:ext uri="{FF2B5EF4-FFF2-40B4-BE49-F238E27FC236}">
-                <a16:creationId xmlns:a16="http://schemas.microsoft.com/office/drawing/2014/main" id="{31EA6037-F96D-4469-9586-BA55D1B2D37B}"/>
+                <a16:creationId xmlns:a16="http://schemas.microsoft.com/office/drawing/2014/main" id="{2DB77EC5-810D-475B-9E49-BD9356E53AA0}"/>
               </a:ext>
             </a:extLst>
           </p:cNvPr>
@@ -3215,7 +3215,7 @@
           <p:cNvPr id="59" name="LLM-side-marker-2">
             <a:extLst xmlns:a="http://schemas.openxmlformats.org/drawingml/2006/main">
               <a:ext uri="{FF2B5EF4-FFF2-40B4-BE49-F238E27FC236}">
-                <a16:creationId xmlns:a16="http://schemas.microsoft.com/office/drawing/2014/main" id="{EC407A07-2FDA-430D-AD88-A68D66161C5F}"/>
+                <a16:creationId xmlns:a16="http://schemas.microsoft.com/office/drawing/2014/main" id="{E912E3D1-C1FB-4EEC-B180-340FE64A7C5D}"/>
               </a:ext>
             </a:extLst>
           </p:cNvPr>
@@ -3248,7 +3248,7 @@
           <p:cNvPr id="60" name="LLM-side-marker-3">
             <a:extLst xmlns:a="http://schemas.openxmlformats.org/drawingml/2006/main">
               <a:ext uri="{FF2B5EF4-FFF2-40B4-BE49-F238E27FC236}">
-                <a16:creationId xmlns:a16="http://schemas.microsoft.com/office/drawing/2014/main" id="{BE58AE9E-39AD-4A33-873C-3B74C475BF71}"/>
+                <a16:creationId xmlns:a16="http://schemas.microsoft.com/office/drawing/2014/main" id="{5611FEDC-632F-4DE5-80C0-4397A722DE53}"/>
               </a:ext>
             </a:extLst>
           </p:cNvPr>
@@ -3281,7 +3281,7 @@
           <p:cNvPr id="61" name="LLM-side-marker-4">
             <a:extLst xmlns:a="http://schemas.openxmlformats.org/drawingml/2006/main">
               <a:ext uri="{FF2B5EF4-FFF2-40B4-BE49-F238E27FC236}">
-                <a16:creationId xmlns:a16="http://schemas.microsoft.com/office/drawing/2014/main" id="{0EDA25F8-EA98-43DF-BBA1-266529A2410D}"/>
+                <a16:creationId xmlns:a16="http://schemas.microsoft.com/office/drawing/2014/main" id="{FDB24E4D-EF9F-4A77-A93F-11035422ED00}"/>
               </a:ext>
             </a:extLst>
           </p:cNvPr>
@@ -3314,7 +3314,7 @@
           <p:cNvPr id="62" name="LLM-side-marker-5">
             <a:extLst xmlns:a="http://schemas.openxmlformats.org/drawingml/2006/main">
               <a:ext uri="{FF2B5EF4-FFF2-40B4-BE49-F238E27FC236}">
-                <a16:creationId xmlns:a16="http://schemas.microsoft.com/office/drawing/2014/main" id="{36A8B15C-6F1F-478F-8E77-77627AFC98F8}"/>
+                <a16:creationId xmlns:a16="http://schemas.microsoft.com/office/drawing/2014/main" id="{686F3008-4BC3-4E7F-A505-01449FFE3043}"/>
               </a:ext>
             </a:extLst>
           </p:cNvPr>
@@ -3347,7 +3347,7 @@
           <p:cNvPr id="63" name="LLM-side-marker-6">
             <a:extLst xmlns:a="http://schemas.openxmlformats.org/drawingml/2006/main">
               <a:ext uri="{FF2B5EF4-FFF2-40B4-BE49-F238E27FC236}">
-                <a16:creationId xmlns:a16="http://schemas.microsoft.com/office/drawing/2014/main" id="{E22AB145-4274-4BE4-8B2A-8AEB9CDF6186}"/>
+                <a16:creationId xmlns:a16="http://schemas.microsoft.com/office/drawing/2014/main" id="{F2CC63E1-F4F7-4C9E-8761-5745DF7C409A}"/>
               </a:ext>
             </a:extLst>
           </p:cNvPr>
@@ -3380,7 +3380,7 @@
           <p:cNvPr id="64" name="LLM-side-marker-7">
             <a:extLst xmlns:a="http://schemas.openxmlformats.org/drawingml/2006/main">
               <a:ext uri="{FF2B5EF4-FFF2-40B4-BE49-F238E27FC236}">
-                <a16:creationId xmlns:a16="http://schemas.microsoft.com/office/drawing/2014/main" id="{8CAA3BD7-25E5-476E-858A-FD2047DBC415}"/>
+                <a16:creationId xmlns:a16="http://schemas.microsoft.com/office/drawing/2014/main" id="{351C040B-080A-4D4D-A4AE-E293AC7A222F}"/>
               </a:ext>
             </a:extLst>
           </p:cNvPr>
@@ -3413,7 +3413,7 @@
           <p:cNvPr id="65" name="LLM-side-marker-8">
             <a:extLst xmlns:a="http://schemas.openxmlformats.org/drawingml/2006/main">
               <a:ext uri="{FF2B5EF4-FFF2-40B4-BE49-F238E27FC236}">
-                <a16:creationId xmlns:a16="http://schemas.microsoft.com/office/drawing/2014/main" id="{D5CF4FF1-0106-4DB6-B3D4-3F4E753CC09E}"/>
+                <a16:creationId xmlns:a16="http://schemas.microsoft.com/office/drawing/2014/main" id="{F0D7966B-2964-42BB-AD4E-56958078197D}"/>
               </a:ext>
             </a:extLst>
           </p:cNvPr>
@@ -3446,7 +3446,7 @@
           <p:cNvPr id="66" name="LLM-side-marker-9">
             <a:extLst xmlns:a="http://schemas.openxmlformats.org/drawingml/2006/main">
               <a:ext uri="{FF2B5EF4-FFF2-40B4-BE49-F238E27FC236}">
-                <a16:creationId xmlns:a16="http://schemas.microsoft.com/office/drawing/2014/main" id="{E13D36B2-9385-4C6A-8685-AF4FD205C723}"/>
+                <a16:creationId xmlns:a16="http://schemas.microsoft.com/office/drawing/2014/main" id="{6D2CBEC0-89E0-45C7-8136-E3624C46C075}"/>
               </a:ext>
             </a:extLst>
           </p:cNvPr>
@@ -3479,7 +3479,7 @@
           <p:cNvPr id="67" name="LLM-side-marker-10">
             <a:extLst xmlns:a="http://schemas.openxmlformats.org/drawingml/2006/main">
               <a:ext uri="{FF2B5EF4-FFF2-40B4-BE49-F238E27FC236}">
-                <a16:creationId xmlns:a16="http://schemas.microsoft.com/office/drawing/2014/main" id="{4A075848-8691-40B3-A6E5-DB0F467DD5C6}"/>
+                <a16:creationId xmlns:a16="http://schemas.microsoft.com/office/drawing/2014/main" id="{AC0AC5CA-A8C9-451A-9CB4-8F5AF37A4093}"/>
               </a:ext>
             </a:extLst>
           </p:cNvPr>
@@ -3512,7 +3512,7 @@
           <p:cNvPr id="68" name="LLM-side-marker-11">
             <a:extLst xmlns:a="http://schemas.openxmlformats.org/drawingml/2006/main">
               <a:ext uri="{FF2B5EF4-FFF2-40B4-BE49-F238E27FC236}">
-                <a16:creationId xmlns:a16="http://schemas.microsoft.com/office/drawing/2014/main" id="{4704391A-11F7-43E5-A8F7-9D83A2B0894C}"/>
+                <a16:creationId xmlns:a16="http://schemas.microsoft.com/office/drawing/2014/main" id="{516555CA-9C5D-46E4-A9C0-00DED98B6027}"/>
               </a:ext>
             </a:extLst>
           </p:cNvPr>
@@ -3545,7 +3545,7 @@
           <p:cNvPr id="69" name="LLM-side-marker-12">
             <a:extLst xmlns:a="http://schemas.openxmlformats.org/drawingml/2006/main">
               <a:ext uri="{FF2B5EF4-FFF2-40B4-BE49-F238E27FC236}">
-                <a16:creationId xmlns:a16="http://schemas.microsoft.com/office/drawing/2014/main" id="{3B683B0B-8BEC-4D76-A318-E461A7FDFD86}"/>
+                <a16:creationId xmlns:a16="http://schemas.microsoft.com/office/drawing/2014/main" id="{481D0075-91D0-42B4-ADD1-D6FEB556AEBD}"/>
               </a:ext>
             </a:extLst>
           </p:cNvPr>
@@ -3578,7 +3578,7 @@
           <p:cNvPr id="70" name="LLM-side-marker-13">
             <a:extLst xmlns:a="http://schemas.openxmlformats.org/drawingml/2006/main">
               <a:ext uri="{FF2B5EF4-FFF2-40B4-BE49-F238E27FC236}">
-                <a16:creationId xmlns:a16="http://schemas.microsoft.com/office/drawing/2014/main" id="{DE8E82ED-BA2F-425F-B31E-4BAD809FE36B}"/>
+                <a16:creationId xmlns:a16="http://schemas.microsoft.com/office/drawing/2014/main" id="{B235DD91-F490-452B-AED9-9C1565AFBDCA}"/>
               </a:ext>
             </a:extLst>
           </p:cNvPr>
@@ -3611,7 +3611,7 @@
           <p:cNvPr id="71" name="LLM-side-marker-14">
             <a:extLst xmlns:a="http://schemas.openxmlformats.org/drawingml/2006/main">
               <a:ext uri="{FF2B5EF4-FFF2-40B4-BE49-F238E27FC236}">
-                <a16:creationId xmlns:a16="http://schemas.microsoft.com/office/drawing/2014/main" id="{817682DD-530F-4898-A3A2-CF5D1A9A3CE6}"/>
+                <a16:creationId xmlns:a16="http://schemas.microsoft.com/office/drawing/2014/main" id="{A47F9739-92B0-466F-B4BB-2773E006676D}"/>
               </a:ext>
             </a:extLst>
           </p:cNvPr>
@@ -3644,7 +3644,7 @@
           <p:cNvPr id="72" name="LLM-side-marker-15">
             <a:extLst xmlns:a="http://schemas.openxmlformats.org/drawingml/2006/main">
               <a:ext uri="{FF2B5EF4-FFF2-40B4-BE49-F238E27FC236}">
-                <a16:creationId xmlns:a16="http://schemas.microsoft.com/office/drawing/2014/main" id="{C457DA81-FC18-4D38-84A2-725E0BCACF67}"/>
+                <a16:creationId xmlns:a16="http://schemas.microsoft.com/office/drawing/2014/main" id="{840A1AE2-35B1-4F2A-91CB-97F83F007F04}"/>
               </a:ext>
             </a:extLst>
           </p:cNvPr>
@@ -3677,7 +3677,7 @@
           <p:cNvPr id="73" name="LLM-side-marker-16">
             <a:extLst xmlns:a="http://schemas.openxmlformats.org/drawingml/2006/main">
               <a:ext uri="{FF2B5EF4-FFF2-40B4-BE49-F238E27FC236}">
-                <a16:creationId xmlns:a16="http://schemas.microsoft.com/office/drawing/2014/main" id="{77AD169F-36F0-4680-B197-7E6F0ED73A63}"/>
+                <a16:creationId xmlns:a16="http://schemas.microsoft.com/office/drawing/2014/main" id="{4BD9497B-CF68-4040-AF29-05AB07593B9E}"/>
               </a:ext>
             </a:extLst>
           </p:cNvPr>
@@ -3710,7 +3710,7 @@
           <p:cNvPr id="74" name="LLM-side-marker-17">
             <a:extLst xmlns:a="http://schemas.openxmlformats.org/drawingml/2006/main">
               <a:ext uri="{FF2B5EF4-FFF2-40B4-BE49-F238E27FC236}">
-                <a16:creationId xmlns:a16="http://schemas.microsoft.com/office/drawing/2014/main" id="{AE95D342-8D13-4063-96E6-44CB9DE7C7CC}"/>
+                <a16:creationId xmlns:a16="http://schemas.microsoft.com/office/drawing/2014/main" id="{80FB30F6-42EB-4FE9-A972-D6D0472DA79C}"/>
               </a:ext>
             </a:extLst>
           </p:cNvPr>
@@ -3743,7 +3743,7 @@
           <p:cNvPr id="75" name="LLM-side-marker-18">
             <a:extLst xmlns:a="http://schemas.openxmlformats.org/drawingml/2006/main">
               <a:ext uri="{FF2B5EF4-FFF2-40B4-BE49-F238E27FC236}">
-                <a16:creationId xmlns:a16="http://schemas.microsoft.com/office/drawing/2014/main" id="{60B1A2FA-C946-4F79-983F-817A0E76B056}"/>
+                <a16:creationId xmlns:a16="http://schemas.microsoft.com/office/drawing/2014/main" id="{B19541D0-AD96-4320-80E9-35F8CCA55DCB}"/>
               </a:ext>
             </a:extLst>
           </p:cNvPr>
@@ -3776,7 +3776,7 @@
           <p:cNvPr id="76" name="LLM-side-marker-19">
             <a:extLst xmlns:a="http://schemas.openxmlformats.org/drawingml/2006/main">
               <a:ext uri="{FF2B5EF4-FFF2-40B4-BE49-F238E27FC236}">
-                <a16:creationId xmlns:a16="http://schemas.microsoft.com/office/drawing/2014/main" id="{A5974A75-9F8B-4C21-8131-0137AC37E553}"/>
+                <a16:creationId xmlns:a16="http://schemas.microsoft.com/office/drawing/2014/main" id="{078E45AB-C132-4FB1-B04B-6479968C3899}"/>
               </a:ext>
             </a:extLst>
           </p:cNvPr>
@@ -3809,7 +3809,7 @@
           <p:cNvPr id="77" name="LLM-side-marker-20">
             <a:extLst xmlns:a="http://schemas.openxmlformats.org/drawingml/2006/main">
               <a:ext uri="{FF2B5EF4-FFF2-40B4-BE49-F238E27FC236}">
-                <a16:creationId xmlns:a16="http://schemas.microsoft.com/office/drawing/2014/main" id="{114F6507-8B7C-403A-9C6F-BFAFEC2DD299}"/>
+                <a16:creationId xmlns:a16="http://schemas.microsoft.com/office/drawing/2014/main" id="{08F6D8DE-1718-44A9-A220-F34D547A3773}"/>
               </a:ext>
             </a:extLst>
           </p:cNvPr>
@@ -3842,7 +3842,7 @@
           <p:cNvPr id="78" name="LLM-side-marker-21">
             <a:extLst xmlns:a="http://schemas.openxmlformats.org/drawingml/2006/main">
               <a:ext uri="{FF2B5EF4-FFF2-40B4-BE49-F238E27FC236}">
-                <a16:creationId xmlns:a16="http://schemas.microsoft.com/office/drawing/2014/main" id="{2B737177-A098-4384-B345-E70E813B2CDC}"/>
+                <a16:creationId xmlns:a16="http://schemas.microsoft.com/office/drawing/2014/main" id="{E53011F1-4A0F-4A54-9F5B-584EA259B1DB}"/>
               </a:ext>
             </a:extLst>
           </p:cNvPr>
@@ -3875,7 +3875,7 @@
           <p:cNvPr id="79" name="LLM-side-marker-22">
             <a:extLst xmlns:a="http://schemas.openxmlformats.org/drawingml/2006/main">
               <a:ext uri="{FF2B5EF4-FFF2-40B4-BE49-F238E27FC236}">
-                <a16:creationId xmlns:a16="http://schemas.microsoft.com/office/drawing/2014/main" id="{C9BCB22C-2763-45FA-8954-DD8A752B34D9}"/>
+                <a16:creationId xmlns:a16="http://schemas.microsoft.com/office/drawing/2014/main" id="{262FD1D8-BBC5-444A-B66A-8C2BB7A2D36B}"/>
               </a:ext>
             </a:extLst>
           </p:cNvPr>
@@ -3908,7 +3908,7 @@
           <p:cNvPr id="80" name="LLM-side-marker-23">
             <a:extLst xmlns:a="http://schemas.openxmlformats.org/drawingml/2006/main">
               <a:ext uri="{FF2B5EF4-FFF2-40B4-BE49-F238E27FC236}">
-                <a16:creationId xmlns:a16="http://schemas.microsoft.com/office/drawing/2014/main" id="{2B02CB4C-24D1-48B2-B4F9-7581D7A5D316}"/>
+                <a16:creationId xmlns:a16="http://schemas.microsoft.com/office/drawing/2014/main" id="{B5429C67-0977-47A3-AD19-97F3018B123D}"/>
               </a:ext>
             </a:extLst>
           </p:cNvPr>
@@ -3941,7 +3941,7 @@
           <p:cNvPr id="81" name="LLM-side-marker-24">
             <a:extLst xmlns:a="http://schemas.openxmlformats.org/drawingml/2006/main">
               <a:ext uri="{FF2B5EF4-FFF2-40B4-BE49-F238E27FC236}">
-                <a16:creationId xmlns:a16="http://schemas.microsoft.com/office/drawing/2014/main" id="{AAF7EA62-6256-44B2-B93F-04234CD44A6D}"/>
+                <a16:creationId xmlns:a16="http://schemas.microsoft.com/office/drawing/2014/main" id="{80266331-1C5C-4305-89A3-6DF6E405B23B}"/>
               </a:ext>
             </a:extLst>
           </p:cNvPr>
@@ -3974,7 +3974,7 @@
           <p:cNvPr id="82" name="LLM-side-marker-25">
             <a:extLst xmlns:a="http://schemas.openxmlformats.org/drawingml/2006/main">
               <a:ext uri="{FF2B5EF4-FFF2-40B4-BE49-F238E27FC236}">
-                <a16:creationId xmlns:a16="http://schemas.microsoft.com/office/drawing/2014/main" id="{2809E545-1AD6-434A-BD98-558440B7557B}"/>
+                <a16:creationId xmlns:a16="http://schemas.microsoft.com/office/drawing/2014/main" id="{18AD8FD6-F351-4AE1-96EE-E5BB2C8D32E7}"/>
               </a:ext>
             </a:extLst>
           </p:cNvPr>
@@ -4007,7 +4007,7 @@
           <p:cNvPr id="83" name="LLM-side-marker-26">
             <a:extLst xmlns:a="http://schemas.openxmlformats.org/drawingml/2006/main">
               <a:ext uri="{FF2B5EF4-FFF2-40B4-BE49-F238E27FC236}">
-                <a16:creationId xmlns:a16="http://schemas.microsoft.com/office/drawing/2014/main" id="{9B1920E2-EED9-4F2D-85CE-B6AD5EE2AE24}"/>
+                <a16:creationId xmlns:a16="http://schemas.microsoft.com/office/drawing/2014/main" id="{85E9B1EB-012C-4CFC-9CCC-6AC5AD330036}"/>
               </a:ext>
             </a:extLst>
           </p:cNvPr>
@@ -4040,7 +4040,7 @@
           <p:cNvPr id="84" name="LLM-side-marker-27">
             <a:extLst xmlns:a="http://schemas.openxmlformats.org/drawingml/2006/main">
               <a:ext uri="{FF2B5EF4-FFF2-40B4-BE49-F238E27FC236}">
-                <a16:creationId xmlns:a16="http://schemas.microsoft.com/office/drawing/2014/main" id="{45CF6F45-FA6F-4988-99D8-AFCEAC0C805B}"/>
+                <a16:creationId xmlns:a16="http://schemas.microsoft.com/office/drawing/2014/main" id="{D7E8F918-AF80-4F91-AE40-924E6EE3E549}"/>
               </a:ext>
             </a:extLst>
           </p:cNvPr>
@@ -4073,7 +4073,7 @@
           <p:cNvPr id="85" name="LLM-side-marker-28">
             <a:extLst xmlns:a="http://schemas.openxmlformats.org/drawingml/2006/main">
               <a:ext uri="{FF2B5EF4-FFF2-40B4-BE49-F238E27FC236}">
-                <a16:creationId xmlns:a16="http://schemas.microsoft.com/office/drawing/2014/main" id="{A14A918D-6B72-4D9C-A5E4-78DB72A5629E}"/>
+                <a16:creationId xmlns:a16="http://schemas.microsoft.com/office/drawing/2014/main" id="{DEC042F1-4305-45C6-864C-1F2FD7AACD56}"/>
               </a:ext>
             </a:extLst>
           </p:cNvPr>
@@ -4106,7 +4106,7 @@
           <p:cNvPr id="86" name="LLM-side-marker-29">
             <a:extLst xmlns:a="http://schemas.openxmlformats.org/drawingml/2006/main">
               <a:ext uri="{FF2B5EF4-FFF2-40B4-BE49-F238E27FC236}">
-                <a16:creationId xmlns:a16="http://schemas.microsoft.com/office/drawing/2014/main" id="{0CE96C9F-4BC3-497A-8537-C69D59FB1758}"/>
+                <a16:creationId xmlns:a16="http://schemas.microsoft.com/office/drawing/2014/main" id="{63BF9047-D464-4D65-993A-3368D5B2E11A}"/>
               </a:ext>
             </a:extLst>
           </p:cNvPr>
@@ -4139,7 +4139,7 @@
           <p:cNvPr id="87" name="General Harness-segment-1">
             <a:extLst xmlns:a="http://schemas.openxmlformats.org/drawingml/2006/main">
               <a:ext uri="{FF2B5EF4-FFF2-40B4-BE49-F238E27FC236}">
-                <a16:creationId xmlns:a16="http://schemas.microsoft.com/office/drawing/2014/main" id="{2235A376-1F23-48DB-819D-C306E9E5D5ED}"/>
+                <a16:creationId xmlns:a16="http://schemas.microsoft.com/office/drawing/2014/main" id="{DC7BD2E3-E20F-4541-A21D-F246D9361FDB}"/>
               </a:ext>
             </a:extLst>
           </p:cNvPr>
@@ -4170,7 +4170,7 @@
           <p:cNvPr id="88" name="General Harness-segment-2">
             <a:extLst xmlns:a="http://schemas.openxmlformats.org/drawingml/2006/main">
               <a:ext uri="{FF2B5EF4-FFF2-40B4-BE49-F238E27FC236}">
-                <a16:creationId xmlns:a16="http://schemas.microsoft.com/office/drawing/2014/main" id="{98E78CB9-72C0-4F56-97DD-B7E133955DE8}"/>
+                <a16:creationId xmlns:a16="http://schemas.microsoft.com/office/drawing/2014/main" id="{9B79BD9D-ECF8-4EE7-86D7-C705396C46F9}"/>
               </a:ext>
             </a:extLst>
           </p:cNvPr>
@@ -4201,7 +4201,7 @@
           <p:cNvPr id="89" name="General Harness-segment-3">
             <a:extLst xmlns:a="http://schemas.openxmlformats.org/drawingml/2006/main">
               <a:ext uri="{FF2B5EF4-FFF2-40B4-BE49-F238E27FC236}">
-                <a16:creationId xmlns:a16="http://schemas.microsoft.com/office/drawing/2014/main" id="{B407C953-FC19-4EF4-AF06-32A631768F2C}"/>
+                <a16:creationId xmlns:a16="http://schemas.microsoft.com/office/drawing/2014/main" id="{CA7EC027-DDB5-43C9-8B24-ACFB6B02032A}"/>
               </a:ext>
             </a:extLst>
           </p:cNvPr>
@@ -4232,7 +4232,7 @@
           <p:cNvPr id="90" name="General Harness-segment-4">
             <a:extLst xmlns:a="http://schemas.openxmlformats.org/drawingml/2006/main">
               <a:ext uri="{FF2B5EF4-FFF2-40B4-BE49-F238E27FC236}">
-                <a16:creationId xmlns:a16="http://schemas.microsoft.com/office/drawing/2014/main" id="{9B01B37C-6243-4DBB-A85F-28DCFC7C81A5}"/>
+                <a16:creationId xmlns:a16="http://schemas.microsoft.com/office/drawing/2014/main" id="{7A35ECF6-EA68-4682-BA50-4875B8324174}"/>
               </a:ext>
             </a:extLst>
           </p:cNvPr>
@@ -4263,7 +4263,7 @@
           <p:cNvPr id="91" name="General Harness-segment-5">
             <a:extLst xmlns:a="http://schemas.openxmlformats.org/drawingml/2006/main">
               <a:ext uri="{FF2B5EF4-FFF2-40B4-BE49-F238E27FC236}">
-                <a16:creationId xmlns:a16="http://schemas.microsoft.com/office/drawing/2014/main" id="{E897F250-33C8-4CF5-B161-34463298DDBD}"/>
+                <a16:creationId xmlns:a16="http://schemas.microsoft.com/office/drawing/2014/main" id="{C4173EA8-9BFD-4D43-BD65-5A3BA8071DD0}"/>
               </a:ext>
             </a:extLst>
           </p:cNvPr>
@@ -4294,7 +4294,7 @@
           <p:cNvPr id="92" name="General Harness-segment-6">
             <a:extLst xmlns:a="http://schemas.openxmlformats.org/drawingml/2006/main">
               <a:ext uri="{FF2B5EF4-FFF2-40B4-BE49-F238E27FC236}">
-                <a16:creationId xmlns:a16="http://schemas.microsoft.com/office/drawing/2014/main" id="{D3324036-399D-46DB-8C5E-C577FB44F74B}"/>
+                <a16:creationId xmlns:a16="http://schemas.microsoft.com/office/drawing/2014/main" id="{80713FD4-8B64-4FFA-BDA2-01893E45B076}"/>
               </a:ext>
             </a:extLst>
           </p:cNvPr>
@@ -4325,7 +4325,7 @@
           <p:cNvPr id="93" name="General Harness-segment-7">
             <a:extLst xmlns:a="http://schemas.openxmlformats.org/drawingml/2006/main">
               <a:ext uri="{FF2B5EF4-FFF2-40B4-BE49-F238E27FC236}">
-                <a16:creationId xmlns:a16="http://schemas.microsoft.com/office/drawing/2014/main" id="{451F8A83-9730-48A8-B21E-5A4A20713FB3}"/>
+                <a16:creationId xmlns:a16="http://schemas.microsoft.com/office/drawing/2014/main" id="{1C1AB35C-A91F-4FA2-9474-3A2997927DE5}"/>
               </a:ext>
             </a:extLst>
           </p:cNvPr>
@@ -4356,7 +4356,7 @@
           <p:cNvPr id="94" name="General Harness-segment-8">
             <a:extLst xmlns:a="http://schemas.openxmlformats.org/drawingml/2006/main">
               <a:ext uri="{FF2B5EF4-FFF2-40B4-BE49-F238E27FC236}">
-                <a16:creationId xmlns:a16="http://schemas.microsoft.com/office/drawing/2014/main" id="{99143028-21AF-4296-9102-6266B79CDC4D}"/>
+                <a16:creationId xmlns:a16="http://schemas.microsoft.com/office/drawing/2014/main" id="{EF80B267-2259-4EA3-879F-BBAE15A619DC}"/>
               </a:ext>
             </a:extLst>
           </p:cNvPr>
@@ -4387,7 +4387,7 @@
           <p:cNvPr id="95" name="General Harness-segment-9">
             <a:extLst xmlns:a="http://schemas.openxmlformats.org/drawingml/2006/main">
               <a:ext uri="{FF2B5EF4-FFF2-40B4-BE49-F238E27FC236}">
-                <a16:creationId xmlns:a16="http://schemas.microsoft.com/office/drawing/2014/main" id="{24F03A0C-72E7-4075-A637-E33E9BBC383C}"/>
+                <a16:creationId xmlns:a16="http://schemas.microsoft.com/office/drawing/2014/main" id="{41341EDA-2090-4B23-B870-273AF5E5F28E}"/>
               </a:ext>
             </a:extLst>
           </p:cNvPr>
@@ -4418,7 +4418,7 @@
           <p:cNvPr id="96" name="General Harness-segment-10">
             <a:extLst xmlns:a="http://schemas.openxmlformats.org/drawingml/2006/main">
               <a:ext uri="{FF2B5EF4-FFF2-40B4-BE49-F238E27FC236}">
-                <a16:creationId xmlns:a16="http://schemas.microsoft.com/office/drawing/2014/main" id="{A8DC6BE2-325F-43D2-8D01-77A8DAB03AD0}"/>
+                <a16:creationId xmlns:a16="http://schemas.microsoft.com/office/drawing/2014/main" id="{FE438012-E076-4D34-A0F5-84CC6546926C}"/>
               </a:ext>
             </a:extLst>
           </p:cNvPr>
@@ -4449,7 +4449,7 @@
           <p:cNvPr id="97" name="General Harness-segment-11">
             <a:extLst xmlns:a="http://schemas.openxmlformats.org/drawingml/2006/main">
               <a:ext uri="{FF2B5EF4-FFF2-40B4-BE49-F238E27FC236}">
-                <a16:creationId xmlns:a16="http://schemas.microsoft.com/office/drawing/2014/main" id="{6DC12A8C-7CE1-4313-9B63-72BAC5690A33}"/>
+                <a16:creationId xmlns:a16="http://schemas.microsoft.com/office/drawing/2014/main" id="{05F806C9-2E31-40C4-9A51-BA5D5DA5C5A5}"/>
               </a:ext>
             </a:extLst>
           </p:cNvPr>
@@ -4480,7 +4480,7 @@
           <p:cNvPr id="98" name="General Harness-segment-12">
             <a:extLst xmlns:a="http://schemas.openxmlformats.org/drawingml/2006/main">
               <a:ext uri="{FF2B5EF4-FFF2-40B4-BE49-F238E27FC236}">
-                <a16:creationId xmlns:a16="http://schemas.microsoft.com/office/drawing/2014/main" id="{3F580694-00BE-43C9-8F79-76C16AA9F266}"/>
+                <a16:creationId xmlns:a16="http://schemas.microsoft.com/office/drawing/2014/main" id="{26B14BBE-98E1-47C9-8688-BA30E1254921}"/>
               </a:ext>
             </a:extLst>
           </p:cNvPr>
@@ -4511,7 +4511,7 @@
           <p:cNvPr id="99" name="General Harness-segment-13">
             <a:extLst xmlns:a="http://schemas.openxmlformats.org/drawingml/2006/main">
               <a:ext uri="{FF2B5EF4-FFF2-40B4-BE49-F238E27FC236}">
-                <a16:creationId xmlns:a16="http://schemas.microsoft.com/office/drawing/2014/main" id="{12784350-831C-425D-B60D-268E1DF71B80}"/>
+                <a16:creationId xmlns:a16="http://schemas.microsoft.com/office/drawing/2014/main" id="{1A637734-E06A-4A54-9083-98CCABEA3200}"/>
               </a:ext>
             </a:extLst>
           </p:cNvPr>
@@ -4542,7 +4542,7 @@
           <p:cNvPr id="100" name="General Harness-segment-14">
             <a:extLst xmlns:a="http://schemas.openxmlformats.org/drawingml/2006/main">
               <a:ext uri="{FF2B5EF4-FFF2-40B4-BE49-F238E27FC236}">
-                <a16:creationId xmlns:a16="http://schemas.microsoft.com/office/drawing/2014/main" id="{8917A2A2-4348-4753-89DC-32640AB67D44}"/>
+                <a16:creationId xmlns:a16="http://schemas.microsoft.com/office/drawing/2014/main" id="{37621E3C-0EB2-4ACA-A844-6AD4E157536D}"/>
               </a:ext>
             </a:extLst>
           </p:cNvPr>
@@ -4573,7 +4573,7 @@
           <p:cNvPr id="101" name="General Harness-segment-15">
             <a:extLst xmlns:a="http://schemas.openxmlformats.org/drawingml/2006/main">
               <a:ext uri="{FF2B5EF4-FFF2-40B4-BE49-F238E27FC236}">
-                <a16:creationId xmlns:a16="http://schemas.microsoft.com/office/drawing/2014/main" id="{C4BE719D-EF32-4ABC-A554-604180D3BA23}"/>
+                <a16:creationId xmlns:a16="http://schemas.microsoft.com/office/drawing/2014/main" id="{3FA7E838-2A60-4D11-ABE1-60421BDA41D5}"/>
               </a:ext>
             </a:extLst>
           </p:cNvPr>
@@ -4604,7 +4604,7 @@
           <p:cNvPr id="102" name="General Harness-segment-16">
             <a:extLst xmlns:a="http://schemas.openxmlformats.org/drawingml/2006/main">
               <a:ext uri="{FF2B5EF4-FFF2-40B4-BE49-F238E27FC236}">
-                <a16:creationId xmlns:a16="http://schemas.microsoft.com/office/drawing/2014/main" id="{83E7A570-662E-49F6-B193-AFD47FBAED19}"/>
+                <a16:creationId xmlns:a16="http://schemas.microsoft.com/office/drawing/2014/main" id="{C76B63E9-D5B7-4025-8FFF-37CCD4743910}"/>
               </a:ext>
             </a:extLst>
           </p:cNvPr>
@@ -4635,7 +4635,7 @@
           <p:cNvPr id="103" name="General Harness-segment-17">
             <a:extLst xmlns:a="http://schemas.openxmlformats.org/drawingml/2006/main">
               <a:ext uri="{FF2B5EF4-FFF2-40B4-BE49-F238E27FC236}">
-                <a16:creationId xmlns:a16="http://schemas.microsoft.com/office/drawing/2014/main" id="{4D6DB165-1A05-4DD3-B943-DD5DE9DA9A73}"/>
+                <a16:creationId xmlns:a16="http://schemas.microsoft.com/office/drawing/2014/main" id="{5BB26E6F-E0B6-49EB-AF76-8DFAD210E952}"/>
               </a:ext>
             </a:extLst>
           </p:cNvPr>
@@ -4666,7 +4666,7 @@
           <p:cNvPr id="104" name="General Harness-segment-18">
             <a:extLst xmlns:a="http://schemas.openxmlformats.org/drawingml/2006/main">
               <a:ext uri="{FF2B5EF4-FFF2-40B4-BE49-F238E27FC236}">
-                <a16:creationId xmlns:a16="http://schemas.microsoft.com/office/drawing/2014/main" id="{FBB98E88-E91F-4ABA-93E0-2422C26C2D89}"/>
+                <a16:creationId xmlns:a16="http://schemas.microsoft.com/office/drawing/2014/main" id="{0E5A3060-9E3E-414B-8514-7654E0F802C6}"/>
               </a:ext>
             </a:extLst>
           </p:cNvPr>
@@ -4697,7 +4697,7 @@
           <p:cNvPr id="105" name="General Harness-segment-19">
             <a:extLst xmlns:a="http://schemas.openxmlformats.org/drawingml/2006/main">
               <a:ext uri="{FF2B5EF4-FFF2-40B4-BE49-F238E27FC236}">
-                <a16:creationId xmlns:a16="http://schemas.microsoft.com/office/drawing/2014/main" id="{D0788BE7-1224-4153-A0C7-77D07D79E450}"/>
+                <a16:creationId xmlns:a16="http://schemas.microsoft.com/office/drawing/2014/main" id="{6DF4C0F1-C68A-4A7C-A39D-B65CC6B68668}"/>
               </a:ext>
             </a:extLst>
           </p:cNvPr>
@@ -4728,7 +4728,7 @@
           <p:cNvPr id="106" name="General Harness-segment-20">
             <a:extLst xmlns:a="http://schemas.openxmlformats.org/drawingml/2006/main">
               <a:ext uri="{FF2B5EF4-FFF2-40B4-BE49-F238E27FC236}">
-                <a16:creationId xmlns:a16="http://schemas.microsoft.com/office/drawing/2014/main" id="{3D8802DA-70C1-42C5-8389-6269B5A24AD1}"/>
+                <a16:creationId xmlns:a16="http://schemas.microsoft.com/office/drawing/2014/main" id="{801A1169-9363-4D4D-96C0-8597625532E8}"/>
               </a:ext>
             </a:extLst>
           </p:cNvPr>
@@ -4759,7 +4759,7 @@
           <p:cNvPr id="107" name="General Harness-segment-21">
             <a:extLst xmlns:a="http://schemas.openxmlformats.org/drawingml/2006/main">
               <a:ext uri="{FF2B5EF4-FFF2-40B4-BE49-F238E27FC236}">
-                <a16:creationId xmlns:a16="http://schemas.microsoft.com/office/drawing/2014/main" id="{1F13795C-4DB7-446A-99DA-4EB1FCA26437}"/>
+                <a16:creationId xmlns:a16="http://schemas.microsoft.com/office/drawing/2014/main" id="{11A9DE11-1A9E-41F5-96CC-C09FDD99F565}"/>
               </a:ext>
             </a:extLst>
           </p:cNvPr>
@@ -4790,7 +4790,7 @@
           <p:cNvPr id="108" name="General Harness-segment-22">
             <a:extLst xmlns:a="http://schemas.openxmlformats.org/drawingml/2006/main">
               <a:ext uri="{FF2B5EF4-FFF2-40B4-BE49-F238E27FC236}">
-                <a16:creationId xmlns:a16="http://schemas.microsoft.com/office/drawing/2014/main" id="{19C6DAC0-21E6-4FB7-B69C-93C421021B2F}"/>
+                <a16:creationId xmlns:a16="http://schemas.microsoft.com/office/drawing/2014/main" id="{6A872804-1019-44FA-B6A3-C092FBD7B293}"/>
               </a:ext>
             </a:extLst>
           </p:cNvPr>
@@ -4821,7 +4821,7 @@
           <p:cNvPr id="109" name="General Harness-segment-23">
             <a:extLst xmlns:a="http://schemas.openxmlformats.org/drawingml/2006/main">
               <a:ext uri="{FF2B5EF4-FFF2-40B4-BE49-F238E27FC236}">
-                <a16:creationId xmlns:a16="http://schemas.microsoft.com/office/drawing/2014/main" id="{052497E7-883E-41EF-934A-BEF3D1290FED}"/>
+                <a16:creationId xmlns:a16="http://schemas.microsoft.com/office/drawing/2014/main" id="{2810199C-62B4-49B5-9324-FADAD409F130}"/>
               </a:ext>
             </a:extLst>
           </p:cNvPr>
@@ -4852,7 +4852,7 @@
           <p:cNvPr id="110" name="General Harness-segment-24">
             <a:extLst xmlns:a="http://schemas.openxmlformats.org/drawingml/2006/main">
               <a:ext uri="{FF2B5EF4-FFF2-40B4-BE49-F238E27FC236}">
-                <a16:creationId xmlns:a16="http://schemas.microsoft.com/office/drawing/2014/main" id="{B46683A4-DAD8-4F5F-9F1A-7FD9A947E2B5}"/>
+                <a16:creationId xmlns:a16="http://schemas.microsoft.com/office/drawing/2014/main" id="{77B36CDF-FEDC-4D06-8D9F-B9822DE777D1}"/>
               </a:ext>
             </a:extLst>
           </p:cNvPr>
@@ -4883,7 +4883,7 @@
           <p:cNvPr id="111" name="General Harness-segment-25">
             <a:extLst xmlns:a="http://schemas.openxmlformats.org/drawingml/2006/main">
               <a:ext uri="{FF2B5EF4-FFF2-40B4-BE49-F238E27FC236}">
-                <a16:creationId xmlns:a16="http://schemas.microsoft.com/office/drawing/2014/main" id="{A82CD1E5-90D0-45BE-AFE5-B163D9E367F2}"/>
+                <a16:creationId xmlns:a16="http://schemas.microsoft.com/office/drawing/2014/main" id="{13DC2C4F-0CB9-43D1-A7B7-C07706DD2F28}"/>
               </a:ext>
             </a:extLst>
           </p:cNvPr>
@@ -4914,7 +4914,7 @@
           <p:cNvPr id="112" name="General Harness-segment-26">
             <a:extLst xmlns:a="http://schemas.openxmlformats.org/drawingml/2006/main">
               <a:ext uri="{FF2B5EF4-FFF2-40B4-BE49-F238E27FC236}">
-                <a16:creationId xmlns:a16="http://schemas.microsoft.com/office/drawing/2014/main" id="{526D62AF-4511-4C5E-9E66-1A1C75507BB4}"/>
+                <a16:creationId xmlns:a16="http://schemas.microsoft.com/office/drawing/2014/main" id="{B9999B24-1CB5-4E34-BA13-2F1BDFA257A7}"/>
               </a:ext>
             </a:extLst>
           </p:cNvPr>
@@ -4945,7 +4945,7 @@
           <p:cNvPr id="113" name="General Harness-segment-27">
             <a:extLst xmlns:a="http://schemas.openxmlformats.org/drawingml/2006/main">
               <a:ext uri="{FF2B5EF4-FFF2-40B4-BE49-F238E27FC236}">
-                <a16:creationId xmlns:a16="http://schemas.microsoft.com/office/drawing/2014/main" id="{13A06E51-DD45-42B3-9A4B-6A679E1F84EF}"/>
+                <a16:creationId xmlns:a16="http://schemas.microsoft.com/office/drawing/2014/main" id="{D51067B5-E1E8-4983-A78E-09E0D4577221}"/>
               </a:ext>
             </a:extLst>
           </p:cNvPr>
@@ -4976,7 +4976,7 @@
           <p:cNvPr id="114" name="General Harness-segment-28">
             <a:extLst xmlns:a="http://schemas.openxmlformats.org/drawingml/2006/main">
               <a:ext uri="{FF2B5EF4-FFF2-40B4-BE49-F238E27FC236}">
-                <a16:creationId xmlns:a16="http://schemas.microsoft.com/office/drawing/2014/main" id="{03489006-52E3-40E2-BFB2-6683A0A86CF7}"/>
+                <a16:creationId xmlns:a16="http://schemas.microsoft.com/office/drawing/2014/main" id="{523A0D3E-BE37-45FD-A16F-9BB28B410CAA}"/>
               </a:ext>
             </a:extLst>
           </p:cNvPr>
@@ -5007,7 +5007,7 @@
           <p:cNvPr id="115" name="General Harness-segment-29">
             <a:extLst xmlns:a="http://schemas.openxmlformats.org/drawingml/2006/main">
               <a:ext uri="{FF2B5EF4-FFF2-40B4-BE49-F238E27FC236}">
-                <a16:creationId xmlns:a16="http://schemas.microsoft.com/office/drawing/2014/main" id="{9A292F0D-63FE-4E4F-AE89-09260CC69CE3}"/>
+                <a16:creationId xmlns:a16="http://schemas.microsoft.com/office/drawing/2014/main" id="{7D3455B8-C082-4E48-84EF-A4CBCDEE01C0}"/>
               </a:ext>
             </a:extLst>
           </p:cNvPr>
@@ -5038,7 +5038,7 @@
           <p:cNvPr id="116" name="General Harness-marker-0">
             <a:extLst xmlns:a="http://schemas.openxmlformats.org/drawingml/2006/main">
               <a:ext uri="{FF2B5EF4-FFF2-40B4-BE49-F238E27FC236}">
-                <a16:creationId xmlns:a16="http://schemas.microsoft.com/office/drawing/2014/main" id="{7E14EC05-DA05-4959-9BCB-0CBDD36793BD}"/>
+                <a16:creationId xmlns:a16="http://schemas.microsoft.com/office/drawing/2014/main" id="{5267A219-64B0-483E-AD54-E1B6084B8AD7}"/>
               </a:ext>
             </a:extLst>
           </p:cNvPr>
@@ -5071,7 +5071,7 @@
           <p:cNvPr id="117" name="General Harness-marker-3">
             <a:extLst xmlns:a="http://schemas.openxmlformats.org/drawingml/2006/main">
               <a:ext uri="{FF2B5EF4-FFF2-40B4-BE49-F238E27FC236}">
-                <a16:creationId xmlns:a16="http://schemas.microsoft.com/office/drawing/2014/main" id="{126EFFB6-F05D-4A41-A233-2ECCB784D0D0}"/>
+                <a16:creationId xmlns:a16="http://schemas.microsoft.com/office/drawing/2014/main" id="{8772310A-5ABA-4963-82D7-14CF93A70B4F}"/>
               </a:ext>
             </a:extLst>
           </p:cNvPr>
@@ -5104,7 +5104,7 @@
           <p:cNvPr id="118" name="General Harness-marker-6">
             <a:extLst xmlns:a="http://schemas.openxmlformats.org/drawingml/2006/main">
               <a:ext uri="{FF2B5EF4-FFF2-40B4-BE49-F238E27FC236}">
-                <a16:creationId xmlns:a16="http://schemas.microsoft.com/office/drawing/2014/main" id="{B08C80B0-58E5-4838-9815-DBF61D73118A}"/>
+                <a16:creationId xmlns:a16="http://schemas.microsoft.com/office/drawing/2014/main" id="{F3407447-DEE0-4835-A10C-CF787468F98A}"/>
               </a:ext>
             </a:extLst>
           </p:cNvPr>
@@ -5137,7 +5137,7 @@
           <p:cNvPr id="119" name="General Harness-marker-9">
             <a:extLst xmlns:a="http://schemas.openxmlformats.org/drawingml/2006/main">
               <a:ext uri="{FF2B5EF4-FFF2-40B4-BE49-F238E27FC236}">
-                <a16:creationId xmlns:a16="http://schemas.microsoft.com/office/drawing/2014/main" id="{94F7BCB5-B99F-4881-9735-AD040672B478}"/>
+                <a16:creationId xmlns:a16="http://schemas.microsoft.com/office/drawing/2014/main" id="{50CA1D9C-17E3-4AD5-B2DB-50FD5990691C}"/>
               </a:ext>
             </a:extLst>
           </p:cNvPr>
@@ -5170,7 +5170,7 @@
           <p:cNvPr id="120" name="General Harness-marker-12">
             <a:extLst xmlns:a="http://schemas.openxmlformats.org/drawingml/2006/main">
               <a:ext uri="{FF2B5EF4-FFF2-40B4-BE49-F238E27FC236}">
-                <a16:creationId xmlns:a16="http://schemas.microsoft.com/office/drawing/2014/main" id="{431D2CFF-FDA0-4548-8369-B4DE8106EF37}"/>
+                <a16:creationId xmlns:a16="http://schemas.microsoft.com/office/drawing/2014/main" id="{DE18F228-8F60-4787-B375-E3F07A5EF94B}"/>
               </a:ext>
             </a:extLst>
           </p:cNvPr>
@@ -5203,7 +5203,7 @@
           <p:cNvPr id="121" name="General Harness-marker-15">
             <a:extLst xmlns:a="http://schemas.openxmlformats.org/drawingml/2006/main">
               <a:ext uri="{FF2B5EF4-FFF2-40B4-BE49-F238E27FC236}">
-                <a16:creationId xmlns:a16="http://schemas.microsoft.com/office/drawing/2014/main" id="{A8DFB3D4-A0D3-47FC-B909-C1FDE5030B1E}"/>
+                <a16:creationId xmlns:a16="http://schemas.microsoft.com/office/drawing/2014/main" id="{7EA4635F-D2A9-40DD-B34B-DEE59188E684}"/>
               </a:ext>
             </a:extLst>
           </p:cNvPr>
@@ -5236,7 +5236,7 @@
           <p:cNvPr id="122" name="General Harness-marker-18">
             <a:extLst xmlns:a="http://schemas.openxmlformats.org/drawingml/2006/main">
               <a:ext uri="{FF2B5EF4-FFF2-40B4-BE49-F238E27FC236}">
-                <a16:creationId xmlns:a16="http://schemas.microsoft.com/office/drawing/2014/main" id="{CB5D383F-528B-415D-AFC6-1DBD1BD5BBD1}"/>
+                <a16:creationId xmlns:a16="http://schemas.microsoft.com/office/drawing/2014/main" id="{2A255BAF-E6A7-4DA2-8A26-7813B1295BC0}"/>
               </a:ext>
             </a:extLst>
           </p:cNvPr>
@@ -5269,7 +5269,7 @@
           <p:cNvPr id="123" name="General Harness-marker-21">
             <a:extLst xmlns:a="http://schemas.openxmlformats.org/drawingml/2006/main">
               <a:ext uri="{FF2B5EF4-FFF2-40B4-BE49-F238E27FC236}">
-                <a16:creationId xmlns:a16="http://schemas.microsoft.com/office/drawing/2014/main" id="{73C83DA5-CAF8-459D-8363-ED82D8D2FC95}"/>
+                <a16:creationId xmlns:a16="http://schemas.microsoft.com/office/drawing/2014/main" id="{F8B5B558-D8BD-4130-A582-E62882560B1C}"/>
               </a:ext>
             </a:extLst>
           </p:cNvPr>
@@ -5302,7 +5302,7 @@
           <p:cNvPr id="124" name="General Harness-marker-24">
             <a:extLst xmlns:a="http://schemas.openxmlformats.org/drawingml/2006/main">
               <a:ext uri="{FF2B5EF4-FFF2-40B4-BE49-F238E27FC236}">
-                <a16:creationId xmlns:a16="http://schemas.microsoft.com/office/drawing/2014/main" id="{A9453036-1671-4F91-AB2B-1DEEA20DA009}"/>
+                <a16:creationId xmlns:a16="http://schemas.microsoft.com/office/drawing/2014/main" id="{F1C043B8-A597-4C02-BF4B-3A60C7D790CD}"/>
               </a:ext>
             </a:extLst>
           </p:cNvPr>
@@ -5335,7 +5335,7 @@
           <p:cNvPr id="125" name="General Harness-marker-27">
             <a:extLst xmlns:a="http://schemas.openxmlformats.org/drawingml/2006/main">
               <a:ext uri="{FF2B5EF4-FFF2-40B4-BE49-F238E27FC236}">
-                <a16:creationId xmlns:a16="http://schemas.microsoft.com/office/drawing/2014/main" id="{A1CAC53D-3B64-458C-B1BA-7A1B7AF9C810}"/>
+                <a16:creationId xmlns:a16="http://schemas.microsoft.com/office/drawing/2014/main" id="{14ADAD5C-A8EF-4C93-963B-48EC02853A1A}"/>
               </a:ext>
             </a:extLst>
           </p:cNvPr>
@@ -5368,7 +5368,7 @@
           <p:cNvPr id="126" name="General Time-Series Harness-segment-1">
             <a:extLst xmlns:a="http://schemas.openxmlformats.org/drawingml/2006/main">
               <a:ext uri="{FF2B5EF4-FFF2-40B4-BE49-F238E27FC236}">
-                <a16:creationId xmlns:a16="http://schemas.microsoft.com/office/drawing/2014/main" id="{AAB279CB-9F77-4A27-B2F7-F63B194C860A}"/>
+                <a16:creationId xmlns:a16="http://schemas.microsoft.com/office/drawing/2014/main" id="{1882F7FD-C0AE-4702-9801-7166CA78A4F5}"/>
               </a:ext>
             </a:extLst>
           </p:cNvPr>
@@ -5399,7 +5399,7 @@
           <p:cNvPr id="127" name="General Time-Series Harness-segment-2">
             <a:extLst xmlns:a="http://schemas.openxmlformats.org/drawingml/2006/main">
               <a:ext uri="{FF2B5EF4-FFF2-40B4-BE49-F238E27FC236}">
-                <a16:creationId xmlns:a16="http://schemas.microsoft.com/office/drawing/2014/main" id="{5720691A-61C3-4FD3-B875-92233446E57D}"/>
+                <a16:creationId xmlns:a16="http://schemas.microsoft.com/office/drawing/2014/main" id="{00EFB545-3711-44FC-9A14-3C99A052B838}"/>
               </a:ext>
             </a:extLst>
           </p:cNvPr>
@@ -5430,7 +5430,7 @@
           <p:cNvPr id="128" name="General Time-Series Harness-segment-3">
             <a:extLst xmlns:a="http://schemas.openxmlformats.org/drawingml/2006/main">
               <a:ext uri="{FF2B5EF4-FFF2-40B4-BE49-F238E27FC236}">
-                <a16:creationId xmlns:a16="http://schemas.microsoft.com/office/drawing/2014/main" id="{0A658066-8643-4EF9-822D-231773563250}"/>
+                <a16:creationId xmlns:a16="http://schemas.microsoft.com/office/drawing/2014/main" id="{36E4944A-0289-4D73-9E05-06EEDC1A340C}"/>
               </a:ext>
             </a:extLst>
           </p:cNvPr>
@@ -5461,7 +5461,7 @@
           <p:cNvPr id="129" name="General Time-Series Harness-segment-4">
             <a:extLst xmlns:a="http://schemas.openxmlformats.org/drawingml/2006/main">
               <a:ext uri="{FF2B5EF4-FFF2-40B4-BE49-F238E27FC236}">
-                <a16:creationId xmlns:a16="http://schemas.microsoft.com/office/drawing/2014/main" id="{7976506E-0FF4-4C50-B3B4-12F4BD227804}"/>
+                <a16:creationId xmlns:a16="http://schemas.microsoft.com/office/drawing/2014/main" id="{EF0621D1-280B-4F8D-AA05-47EA5B1CD67B}"/>
               </a:ext>
             </a:extLst>
           </p:cNvPr>
@@ -5492,7 +5492,7 @@
           <p:cNvPr id="130" name="General Time-Series Harness-segment-5">
             <a:extLst xmlns:a="http://schemas.openxmlformats.org/drawingml/2006/main">
               <a:ext uri="{FF2B5EF4-FFF2-40B4-BE49-F238E27FC236}">
-                <a16:creationId xmlns:a16="http://schemas.microsoft.com/office/drawing/2014/main" id="{BDF87E57-D474-4008-82A2-4C23F791F8E0}"/>
+                <a16:creationId xmlns:a16="http://schemas.microsoft.com/office/drawing/2014/main" id="{50A273F5-9085-4199-AB88-24E2D2698E6D}"/>
               </a:ext>
             </a:extLst>
           </p:cNvPr>
@@ -5523,7 +5523,7 @@
           <p:cNvPr id="131" name="General Time-Series Harness-segment-6">
             <a:extLst xmlns:a="http://schemas.openxmlformats.org/drawingml/2006/main">
               <a:ext uri="{FF2B5EF4-FFF2-40B4-BE49-F238E27FC236}">
-                <a16:creationId xmlns:a16="http://schemas.microsoft.com/office/drawing/2014/main" id="{BF4D5C6B-7F0A-4C94-8388-F9AAABAD2916}"/>
+                <a16:creationId xmlns:a16="http://schemas.microsoft.com/office/drawing/2014/main" id="{72EC4161-71B0-4AD2-A69A-7E881FF8FA0E}"/>
               </a:ext>
             </a:extLst>
           </p:cNvPr>
@@ -5554,7 +5554,7 @@
           <p:cNvPr id="132" name="General Time-Series Harness-segment-7">
             <a:extLst xmlns:a="http://schemas.openxmlformats.org/drawingml/2006/main">
               <a:ext uri="{FF2B5EF4-FFF2-40B4-BE49-F238E27FC236}">
-                <a16:creationId xmlns:a16="http://schemas.microsoft.com/office/drawing/2014/main" id="{F3B0C825-6E99-46FA-A68C-9695D6D39CAA}"/>
+                <a16:creationId xmlns:a16="http://schemas.microsoft.com/office/drawing/2014/main" id="{9DA4E156-0616-4F44-AF9B-5E49E0866CD5}"/>
               </a:ext>
             </a:extLst>
           </p:cNvPr>
@@ -5585,7 +5585,7 @@
           <p:cNvPr id="133" name="General Time-Series Harness-segment-8">
             <a:extLst xmlns:a="http://schemas.openxmlformats.org/drawingml/2006/main">
               <a:ext uri="{FF2B5EF4-FFF2-40B4-BE49-F238E27FC236}">
-                <a16:creationId xmlns:a16="http://schemas.microsoft.com/office/drawing/2014/main" id="{B4CBA0AA-E14B-4D7D-8ECA-AE86D4A9C696}"/>
+                <a16:creationId xmlns:a16="http://schemas.microsoft.com/office/drawing/2014/main" id="{B8AF28C5-653A-4193-AAF7-8A1D618F4813}"/>
               </a:ext>
             </a:extLst>
           </p:cNvPr>
@@ -5616,7 +5616,7 @@
           <p:cNvPr id="134" name="General Time-Series Harness-segment-9">
             <a:extLst xmlns:a="http://schemas.openxmlformats.org/drawingml/2006/main">
               <a:ext uri="{FF2B5EF4-FFF2-40B4-BE49-F238E27FC236}">
-                <a16:creationId xmlns:a16="http://schemas.microsoft.com/office/drawing/2014/main" id="{34DB3A6A-ACCF-4C22-B3A2-265EC92A7686}"/>
+                <a16:creationId xmlns:a16="http://schemas.microsoft.com/office/drawing/2014/main" id="{423C6243-356E-4A3C-9795-E2460A8C9EF4}"/>
               </a:ext>
             </a:extLst>
           </p:cNvPr>
@@ -5647,7 +5647,7 @@
           <p:cNvPr id="135" name="General Time-Series Harness-segment-10">
             <a:extLst xmlns:a="http://schemas.openxmlformats.org/drawingml/2006/main">
               <a:ext uri="{FF2B5EF4-FFF2-40B4-BE49-F238E27FC236}">
-                <a16:creationId xmlns:a16="http://schemas.microsoft.com/office/drawing/2014/main" id="{B94EB28B-4DDF-433A-A2DC-1E56793D45EE}"/>
+                <a16:creationId xmlns:a16="http://schemas.microsoft.com/office/drawing/2014/main" id="{4CBDEA18-46A3-48AB-8EFF-DFDC554DCB5E}"/>
               </a:ext>
             </a:extLst>
           </p:cNvPr>
@@ -5678,7 +5678,7 @@
           <p:cNvPr id="136" name="General Time-Series Harness-segment-11">
             <a:extLst xmlns:a="http://schemas.openxmlformats.org/drawingml/2006/main">
               <a:ext uri="{FF2B5EF4-FFF2-40B4-BE49-F238E27FC236}">
-                <a16:creationId xmlns:a16="http://schemas.microsoft.com/office/drawing/2014/main" id="{79CEC743-490A-497A-8067-4F19DCD3ED2E}"/>
+                <a16:creationId xmlns:a16="http://schemas.microsoft.com/office/drawing/2014/main" id="{852C0F86-F48C-461C-9AB9-C2C283E8510E}"/>
               </a:ext>
             </a:extLst>
           </p:cNvPr>
@@ -5709,7 +5709,7 @@
           <p:cNvPr id="137" name="General Time-Series Harness-segment-12">
             <a:extLst xmlns:a="http://schemas.openxmlformats.org/drawingml/2006/main">
               <a:ext uri="{FF2B5EF4-FFF2-40B4-BE49-F238E27FC236}">
-                <a16:creationId xmlns:a16="http://schemas.microsoft.com/office/drawing/2014/main" id="{83E31A27-DC79-444F-8733-57615B2D0A18}"/>
+                <a16:creationId xmlns:a16="http://schemas.microsoft.com/office/drawing/2014/main" id="{B3E2BD35-E93A-4B3C-B252-CB9FE8A456FB}"/>
               </a:ext>
             </a:extLst>
           </p:cNvPr>
@@ -5740,7 +5740,7 @@
           <p:cNvPr id="138" name="General Time-Series Harness-segment-13">
             <a:extLst xmlns:a="http://schemas.openxmlformats.org/drawingml/2006/main">
               <a:ext uri="{FF2B5EF4-FFF2-40B4-BE49-F238E27FC236}">
-                <a16:creationId xmlns:a16="http://schemas.microsoft.com/office/drawing/2014/main" id="{A8EFC0B9-AF5C-41ED-B175-6B8377D6841F}"/>
+                <a16:creationId xmlns:a16="http://schemas.microsoft.com/office/drawing/2014/main" id="{DF6BDE85-0CB2-4011-9D5B-15C4C74565AF}"/>
               </a:ext>
             </a:extLst>
           </p:cNvPr>
@@ -5771,7 +5771,7 @@
           <p:cNvPr id="139" name="General Time-Series Harness-segment-14">
             <a:extLst xmlns:a="http://schemas.openxmlformats.org/drawingml/2006/main">
               <a:ext uri="{FF2B5EF4-FFF2-40B4-BE49-F238E27FC236}">
-                <a16:creationId xmlns:a16="http://schemas.microsoft.com/office/drawing/2014/main" id="{5834D549-A2D1-4464-86FD-F6731143DD3C}"/>
+                <a16:creationId xmlns:a16="http://schemas.microsoft.com/office/drawing/2014/main" id="{41EB9206-DC2F-40EE-9822-2792ACA87D06}"/>
               </a:ext>
             </a:extLst>
           </p:cNvPr>
@@ -5802,7 +5802,7 @@
           <p:cNvPr id="140" name="General Time-Series Harness-segment-15">
             <a:extLst xmlns:a="http://schemas.openxmlformats.org/drawingml/2006/main">
               <a:ext uri="{FF2B5EF4-FFF2-40B4-BE49-F238E27FC236}">
-                <a16:creationId xmlns:a16="http://schemas.microsoft.com/office/drawing/2014/main" id="{503EBB8B-2B38-476F-9BAE-CE9FA885F52E}"/>
+                <a16:creationId xmlns:a16="http://schemas.microsoft.com/office/drawing/2014/main" id="{A9F97DDD-10B9-4BFF-8118-AA0F68804160}"/>
               </a:ext>
             </a:extLst>
           </p:cNvPr>
@@ -5833,7 +5833,7 @@
           <p:cNvPr id="141" name="General Time-Series Harness-segment-16">
             <a:extLst xmlns:a="http://schemas.openxmlformats.org/drawingml/2006/main">
               <a:ext uri="{FF2B5EF4-FFF2-40B4-BE49-F238E27FC236}">
-                <a16:creationId xmlns:a16="http://schemas.microsoft.com/office/drawing/2014/main" id="{F9562DB4-F39F-488C-AF67-13AE4AAFE130}"/>
+                <a16:creationId xmlns:a16="http://schemas.microsoft.com/office/drawing/2014/main" id="{02ED8CBF-BD81-44AA-A617-DC49D7BB0974}"/>
               </a:ext>
             </a:extLst>
           </p:cNvPr>
@@ -5864,7 +5864,7 @@
           <p:cNvPr id="142" name="General Time-Series Harness-segment-17">
             <a:extLst xmlns:a="http://schemas.openxmlformats.org/drawingml/2006/main">
               <a:ext uri="{FF2B5EF4-FFF2-40B4-BE49-F238E27FC236}">
-                <a16:creationId xmlns:a16="http://schemas.microsoft.com/office/drawing/2014/main" id="{256688B2-0696-4ADC-AB5F-6D1D5CB563D1}"/>
+                <a16:creationId xmlns:a16="http://schemas.microsoft.com/office/drawing/2014/main" id="{D0B84FDC-4ED3-4BBC-8F50-235D3CB65389}"/>
               </a:ext>
             </a:extLst>
           </p:cNvPr>
@@ -5895,7 +5895,7 @@
           <p:cNvPr id="143" name="General Time-Series Harness-segment-18">
             <a:extLst xmlns:a="http://schemas.openxmlformats.org/drawingml/2006/main">
               <a:ext uri="{FF2B5EF4-FFF2-40B4-BE49-F238E27FC236}">
-                <a16:creationId xmlns:a16="http://schemas.microsoft.com/office/drawing/2014/main" id="{51250F1B-E294-4827-A43A-4C8281A21C12}"/>
+                <a16:creationId xmlns:a16="http://schemas.microsoft.com/office/drawing/2014/main" id="{F07D16CA-6E32-478D-B46A-53000DB2B9F5}"/>
               </a:ext>
             </a:extLst>
           </p:cNvPr>
@@ -5926,7 +5926,7 @@
           <p:cNvPr id="144" name="General Time-Series Harness-segment-19">
             <a:extLst xmlns:a="http://schemas.openxmlformats.org/drawingml/2006/main">
               <a:ext uri="{FF2B5EF4-FFF2-40B4-BE49-F238E27FC236}">
-                <a16:creationId xmlns:a16="http://schemas.microsoft.com/office/drawing/2014/main" id="{0EE0F4CC-6A00-47CD-B34B-06B13A876589}"/>
+                <a16:creationId xmlns:a16="http://schemas.microsoft.com/office/drawing/2014/main" id="{2484C5DC-F353-4F53-ADDB-88CC60784138}"/>
               </a:ext>
             </a:extLst>
           </p:cNvPr>
@@ -5957,7 +5957,7 @@
           <p:cNvPr id="145" name="General Time-Series Harness-segment-20">
             <a:extLst xmlns:a="http://schemas.openxmlformats.org/drawingml/2006/main">
               <a:ext uri="{FF2B5EF4-FFF2-40B4-BE49-F238E27FC236}">
-                <a16:creationId xmlns:a16="http://schemas.microsoft.com/office/drawing/2014/main" id="{A994A044-5EA8-4B42-B81B-0527D69B9678}"/>
+                <a16:creationId xmlns:a16="http://schemas.microsoft.com/office/drawing/2014/main" id="{8486660E-2033-41F5-B5CF-E2F462B9C2D8}"/>
               </a:ext>
             </a:extLst>
           </p:cNvPr>
@@ -5988,7 +5988,7 @@
           <p:cNvPr id="146" name="General Time-Series Harness-segment-21">
             <a:extLst xmlns:a="http://schemas.openxmlformats.org/drawingml/2006/main">
               <a:ext uri="{FF2B5EF4-FFF2-40B4-BE49-F238E27FC236}">
-                <a16:creationId xmlns:a16="http://schemas.microsoft.com/office/drawing/2014/main" id="{A4A7E56D-E964-48DC-9A70-D79FD97EEDFE}"/>
+                <a16:creationId xmlns:a16="http://schemas.microsoft.com/office/drawing/2014/main" id="{42B4F69A-F245-4FD0-AB2D-943D1349943B}"/>
               </a:ext>
             </a:extLst>
           </p:cNvPr>
@@ -6019,7 +6019,7 @@
           <p:cNvPr id="147" name="General Time-Series Harness-segment-22">
             <a:extLst xmlns:a="http://schemas.openxmlformats.org/drawingml/2006/main">
               <a:ext uri="{FF2B5EF4-FFF2-40B4-BE49-F238E27FC236}">
-                <a16:creationId xmlns:a16="http://schemas.microsoft.com/office/drawing/2014/main" id="{B99BA0AC-C85F-4AC6-8F98-12AECF7770F8}"/>
+                <a16:creationId xmlns:a16="http://schemas.microsoft.com/office/drawing/2014/main" id="{799A93F5-FBF7-44F8-89C5-27E2957B4044}"/>
               </a:ext>
             </a:extLst>
           </p:cNvPr>
@@ -6050,7 +6050,7 @@
           <p:cNvPr id="148" name="General Time-Series Harness-segment-23">
             <a:extLst xmlns:a="http://schemas.openxmlformats.org/drawingml/2006/main">
               <a:ext uri="{FF2B5EF4-FFF2-40B4-BE49-F238E27FC236}">
-                <a16:creationId xmlns:a16="http://schemas.microsoft.com/office/drawing/2014/main" id="{4623AB33-A658-4380-A89D-65B3BFFCD48E}"/>
+                <a16:creationId xmlns:a16="http://schemas.microsoft.com/office/drawing/2014/main" id="{31C88222-3FE5-4249-8260-358463ADDC07}"/>
               </a:ext>
             </a:extLst>
           </p:cNvPr>
@@ -6081,7 +6081,7 @@
           <p:cNvPr id="149" name="General Time-Series Harness-segment-24">
             <a:extLst xmlns:a="http://schemas.openxmlformats.org/drawingml/2006/main">
               <a:ext uri="{FF2B5EF4-FFF2-40B4-BE49-F238E27FC236}">
-                <a16:creationId xmlns:a16="http://schemas.microsoft.com/office/drawing/2014/main" id="{5AE2E608-D48D-4064-AA6F-FD82E68AA780}"/>
+                <a16:creationId xmlns:a16="http://schemas.microsoft.com/office/drawing/2014/main" id="{103E923A-4BFB-4AC6-9CFE-3077E122566B}"/>
               </a:ext>
             </a:extLst>
           </p:cNvPr>
@@ -6112,7 +6112,7 @@
           <p:cNvPr id="150" name="General Time-Series Harness-segment-25">
             <a:extLst xmlns:a="http://schemas.openxmlformats.org/drawingml/2006/main">
               <a:ext uri="{FF2B5EF4-FFF2-40B4-BE49-F238E27FC236}">
-                <a16:creationId xmlns:a16="http://schemas.microsoft.com/office/drawing/2014/main" id="{D66811AD-86B7-4FBE-8E95-E16DEA978D7E}"/>
+                <a16:creationId xmlns:a16="http://schemas.microsoft.com/office/drawing/2014/main" id="{FDD85100-D557-4827-9A5E-39E7C99AAA97}"/>
               </a:ext>
             </a:extLst>
           </p:cNvPr>
@@ -6143,7 +6143,7 @@
           <p:cNvPr id="151" name="General Time-Series Harness-segment-26">
             <a:extLst xmlns:a="http://schemas.openxmlformats.org/drawingml/2006/main">
               <a:ext uri="{FF2B5EF4-FFF2-40B4-BE49-F238E27FC236}">
-                <a16:creationId xmlns:a16="http://schemas.microsoft.com/office/drawing/2014/main" id="{F47FFAA7-F233-4654-8721-74FD333EA177}"/>
+                <a16:creationId xmlns:a16="http://schemas.microsoft.com/office/drawing/2014/main" id="{529DC670-1DAC-4B2C-868F-B00B83B9C735}"/>
               </a:ext>
             </a:extLst>
           </p:cNvPr>
@@ -6174,7 +6174,7 @@
           <p:cNvPr id="152" name="General Time-Series Harness-segment-27">
             <a:extLst xmlns:a="http://schemas.openxmlformats.org/drawingml/2006/main">
               <a:ext uri="{FF2B5EF4-FFF2-40B4-BE49-F238E27FC236}">
-                <a16:creationId xmlns:a16="http://schemas.microsoft.com/office/drawing/2014/main" id="{46DCA193-433E-4C9F-A151-40F2802B5A08}"/>
+                <a16:creationId xmlns:a16="http://schemas.microsoft.com/office/drawing/2014/main" id="{A1D46C33-40B4-4CFD-854B-DE95BFD94286}"/>
               </a:ext>
             </a:extLst>
           </p:cNvPr>
@@ -6205,7 +6205,7 @@
           <p:cNvPr id="153" name="General Time-Series Harness-segment-28">
             <a:extLst xmlns:a="http://schemas.openxmlformats.org/drawingml/2006/main">
               <a:ext uri="{FF2B5EF4-FFF2-40B4-BE49-F238E27FC236}">
-                <a16:creationId xmlns:a16="http://schemas.microsoft.com/office/drawing/2014/main" id="{B685B524-A06E-4D6E-A5DE-A71BC3333DD0}"/>
+                <a16:creationId xmlns:a16="http://schemas.microsoft.com/office/drawing/2014/main" id="{CC282D36-E859-4E41-895C-8C32111937EE}"/>
               </a:ext>
             </a:extLst>
           </p:cNvPr>
@@ -6236,7 +6236,7 @@
           <p:cNvPr id="154" name="General Time-Series Harness-segment-29">
             <a:extLst xmlns:a="http://schemas.openxmlformats.org/drawingml/2006/main">
               <a:ext uri="{FF2B5EF4-FFF2-40B4-BE49-F238E27FC236}">
-                <a16:creationId xmlns:a16="http://schemas.microsoft.com/office/drawing/2014/main" id="{82920309-FBE1-4C70-AB29-CC516EE7DDFB}"/>
+                <a16:creationId xmlns:a16="http://schemas.microsoft.com/office/drawing/2014/main" id="{DBE2AABE-D0CA-459F-861B-77388CA43FB8}"/>
               </a:ext>
             </a:extLst>
           </p:cNvPr>
@@ -6267,7 +6267,7 @@
           <p:cNvPr id="155" name="General Time-Series Harness-marker-0">
             <a:extLst xmlns:a="http://schemas.openxmlformats.org/drawingml/2006/main">
               <a:ext uri="{FF2B5EF4-FFF2-40B4-BE49-F238E27FC236}">
-                <a16:creationId xmlns:a16="http://schemas.microsoft.com/office/drawing/2014/main" id="{D78CD6FF-D9B8-44D6-9CC5-111ADD3E8F9E}"/>
+                <a16:creationId xmlns:a16="http://schemas.microsoft.com/office/drawing/2014/main" id="{A0E523F4-1601-4F47-8B42-475AEA37D702}"/>
               </a:ext>
             </a:extLst>
           </p:cNvPr>
@@ -6300,7 +6300,7 @@
           <p:cNvPr id="156" name="General Time-Series Harness-marker-1">
             <a:extLst xmlns:a="http://schemas.openxmlformats.org/drawingml/2006/main">
               <a:ext uri="{FF2B5EF4-FFF2-40B4-BE49-F238E27FC236}">
-                <a16:creationId xmlns:a16="http://schemas.microsoft.com/office/drawing/2014/main" id="{9A63BD16-27EF-4B59-9471-C50C299E5B2F}"/>
+                <a16:creationId xmlns:a16="http://schemas.microsoft.com/office/drawing/2014/main" id="{0D05E52A-50C1-46B9-ABAF-75163A70C46C}"/>
               </a:ext>
             </a:extLst>
           </p:cNvPr>
@@ -6333,7 +6333,7 @@
           <p:cNvPr id="157" name="General Time-Series Harness-marker-2">
             <a:extLst xmlns:a="http://schemas.openxmlformats.org/drawingml/2006/main">
               <a:ext uri="{FF2B5EF4-FFF2-40B4-BE49-F238E27FC236}">
-                <a16:creationId xmlns:a16="http://schemas.microsoft.com/office/drawing/2014/main" id="{3F9A6E09-08B2-41FB-87C1-8D4E0A3EFE73}"/>
+                <a16:creationId xmlns:a16="http://schemas.microsoft.com/office/drawing/2014/main" id="{F7B91A99-0E0C-4952-9250-A38C68EBA4A7}"/>
               </a:ext>
             </a:extLst>
           </p:cNvPr>
@@ -6366,7 +6366,7 @@
           <p:cNvPr id="158" name="General Time-Series Harness-marker-3">
             <a:extLst xmlns:a="http://schemas.openxmlformats.org/drawingml/2006/main">
               <a:ext uri="{FF2B5EF4-FFF2-40B4-BE49-F238E27FC236}">
-                <a16:creationId xmlns:a16="http://schemas.microsoft.com/office/drawing/2014/main" id="{7C42DE7B-501F-44B6-AA04-5FD69A24AAE2}"/>
+                <a16:creationId xmlns:a16="http://schemas.microsoft.com/office/drawing/2014/main" id="{7123F998-B8C5-4CF7-8A81-9745E0E94EEA}"/>
               </a:ext>
             </a:extLst>
           </p:cNvPr>
@@ -6399,7 +6399,7 @@
           <p:cNvPr id="159" name="General Time-Series Harness-marker-4">
             <a:extLst xmlns:a="http://schemas.openxmlformats.org/drawingml/2006/main">
               <a:ext uri="{FF2B5EF4-FFF2-40B4-BE49-F238E27FC236}">
-                <a16:creationId xmlns:a16="http://schemas.microsoft.com/office/drawing/2014/main" id="{A0068F5E-F390-4AEA-A7A1-D403545EF9E7}"/>
+                <a16:creationId xmlns:a16="http://schemas.microsoft.com/office/drawing/2014/main" id="{D7B5CD0F-3C6F-4BB2-BC09-41912BE7A4F9}"/>
               </a:ext>
             </a:extLst>
           </p:cNvPr>
@@ -6432,7 +6432,7 @@
           <p:cNvPr id="160" name="General Time-Series Harness-marker-5">
             <a:extLst xmlns:a="http://schemas.openxmlformats.org/drawingml/2006/main">
               <a:ext uri="{FF2B5EF4-FFF2-40B4-BE49-F238E27FC236}">
-                <a16:creationId xmlns:a16="http://schemas.microsoft.com/office/drawing/2014/main" id="{92DE93FF-A61E-4612-916B-ED1059A700BE}"/>
+                <a16:creationId xmlns:a16="http://schemas.microsoft.com/office/drawing/2014/main" id="{AF53B48B-0992-4BAE-ABC0-EB9FCEF85585}"/>
               </a:ext>
             </a:extLst>
           </p:cNvPr>
@@ -6465,7 +6465,7 @@
           <p:cNvPr id="161" name="General Time-Series Harness-marker-6">
             <a:extLst xmlns:a="http://schemas.openxmlformats.org/drawingml/2006/main">
               <a:ext uri="{FF2B5EF4-FFF2-40B4-BE49-F238E27FC236}">
-                <a16:creationId xmlns:a16="http://schemas.microsoft.com/office/drawing/2014/main" id="{79B7A7AE-5B29-43F5-B950-E6E4A3B27501}"/>
+                <a16:creationId xmlns:a16="http://schemas.microsoft.com/office/drawing/2014/main" id="{26B2C2A7-5783-45A9-8983-D5B3E0F4E80C}"/>
               </a:ext>
             </a:extLst>
           </p:cNvPr>
@@ -6498,7 +6498,7 @@
           <p:cNvPr id="162" name="General Time-Series Harness-marker-7">
             <a:extLst xmlns:a="http://schemas.openxmlformats.org/drawingml/2006/main">
               <a:ext uri="{FF2B5EF4-FFF2-40B4-BE49-F238E27FC236}">
-                <a16:creationId xmlns:a16="http://schemas.microsoft.com/office/drawing/2014/main" id="{3F1F1D8B-03F3-4741-81D8-618EC27D1C8C}"/>
+                <a16:creationId xmlns:a16="http://schemas.microsoft.com/office/drawing/2014/main" id="{F786FE46-406B-4A16-9A75-7780F075AAA3}"/>
               </a:ext>
             </a:extLst>
           </p:cNvPr>
@@ -6531,7 +6531,7 @@
           <p:cNvPr id="163" name="General Time-Series Harness-marker-8">
             <a:extLst xmlns:a="http://schemas.openxmlformats.org/drawingml/2006/main">
               <a:ext uri="{FF2B5EF4-FFF2-40B4-BE49-F238E27FC236}">
-                <a16:creationId xmlns:a16="http://schemas.microsoft.com/office/drawing/2014/main" id="{18425236-46FA-4442-AEF0-98EBDFA48C21}"/>
+                <a16:creationId xmlns:a16="http://schemas.microsoft.com/office/drawing/2014/main" id="{6CF18663-F252-4E7E-8D2A-47A2435B2CCB}"/>
               </a:ext>
             </a:extLst>
           </p:cNvPr>
@@ -6564,7 +6564,7 @@
           <p:cNvPr id="164" name="General Time-Series Harness-marker-9">
             <a:extLst xmlns:a="http://schemas.openxmlformats.org/drawingml/2006/main">
               <a:ext uri="{FF2B5EF4-FFF2-40B4-BE49-F238E27FC236}">
-                <a16:creationId xmlns:a16="http://schemas.microsoft.com/office/drawing/2014/main" id="{73A222E8-30B2-4DF2-9148-325611611577}"/>
+                <a16:creationId xmlns:a16="http://schemas.microsoft.com/office/drawing/2014/main" id="{9E9C1592-42BE-4919-8454-9E248A446C6E}"/>
               </a:ext>
             </a:extLst>
           </p:cNvPr>
@@ -6597,7 +6597,7 @@
           <p:cNvPr id="165" name="General Time-Series Harness-marker-10">
             <a:extLst xmlns:a="http://schemas.openxmlformats.org/drawingml/2006/main">
               <a:ext uri="{FF2B5EF4-FFF2-40B4-BE49-F238E27FC236}">
-                <a16:creationId xmlns:a16="http://schemas.microsoft.com/office/drawing/2014/main" id="{BEFB6E48-8559-46AD-975C-CC2E41BBFF85}"/>
+                <a16:creationId xmlns:a16="http://schemas.microsoft.com/office/drawing/2014/main" id="{A24C3C30-99A4-49D7-998B-61C8B1F202E9}"/>
               </a:ext>
             </a:extLst>
           </p:cNvPr>
@@ -6630,7 +6630,7 @@
           <p:cNvPr id="166" name="General Time-Series Harness-marker-11">
             <a:extLst xmlns:a="http://schemas.openxmlformats.org/drawingml/2006/main">
               <a:ext uri="{FF2B5EF4-FFF2-40B4-BE49-F238E27FC236}">
-                <a16:creationId xmlns:a16="http://schemas.microsoft.com/office/drawing/2014/main" id="{901D2B93-B0ED-47C3-AD46-FAE10CC7CD17}"/>
+                <a16:creationId xmlns:a16="http://schemas.microsoft.com/office/drawing/2014/main" id="{97C7C3F8-9614-4F63-86B5-027A58F3E466}"/>
               </a:ext>
             </a:extLst>
           </p:cNvPr>
@@ -6663,7 +6663,7 @@
           <p:cNvPr id="167" name="General Time-Series Harness-marker-12">
             <a:extLst xmlns:a="http://schemas.openxmlformats.org/drawingml/2006/main">
               <a:ext uri="{FF2B5EF4-FFF2-40B4-BE49-F238E27FC236}">
-                <a16:creationId xmlns:a16="http://schemas.microsoft.com/office/drawing/2014/main" id="{D5549E5E-7B6E-4D35-B9E6-8A0BEF2978DC}"/>
+                <a16:creationId xmlns:a16="http://schemas.microsoft.com/office/drawing/2014/main" id="{3212DF8E-C02F-4771-8A5B-0ECCA44B7C23}"/>
               </a:ext>
             </a:extLst>
           </p:cNvPr>
@@ -6696,7 +6696,7 @@
           <p:cNvPr id="168" name="General Time-Series Harness-marker-13">
             <a:extLst xmlns:a="http://schemas.openxmlformats.org/drawingml/2006/main">
               <a:ext uri="{FF2B5EF4-FFF2-40B4-BE49-F238E27FC236}">
-                <a16:creationId xmlns:a16="http://schemas.microsoft.com/office/drawing/2014/main" id="{2C0BC302-7141-4676-BFA7-AFB181B68755}"/>
+                <a16:creationId xmlns:a16="http://schemas.microsoft.com/office/drawing/2014/main" id="{BF14F563-0103-4474-AB78-099C3A0FCB9B}"/>
               </a:ext>
             </a:extLst>
           </p:cNvPr>
@@ -6729,7 +6729,7 @@
           <p:cNvPr id="169" name="General Time-Series Harness-marker-14">
             <a:extLst xmlns:a="http://schemas.openxmlformats.org/drawingml/2006/main">
               <a:ext uri="{FF2B5EF4-FFF2-40B4-BE49-F238E27FC236}">
-                <a16:creationId xmlns:a16="http://schemas.microsoft.com/office/drawing/2014/main" id="{B647583A-ED1C-4288-A83A-44484A084A92}"/>
+                <a16:creationId xmlns:a16="http://schemas.microsoft.com/office/drawing/2014/main" id="{6E76390E-2AFE-42A0-9C1C-586C8A1C8F1D}"/>
               </a:ext>
             </a:extLst>
           </p:cNvPr>
@@ -6762,7 +6762,7 @@
           <p:cNvPr id="170" name="General Time-Series Harness-marker-15">
             <a:extLst xmlns:a="http://schemas.openxmlformats.org/drawingml/2006/main">
               <a:ext uri="{FF2B5EF4-FFF2-40B4-BE49-F238E27FC236}">
-                <a16:creationId xmlns:a16="http://schemas.microsoft.com/office/drawing/2014/main" id="{5BA581DB-9D2F-437B-ABDB-E2F79634935F}"/>
+                <a16:creationId xmlns:a16="http://schemas.microsoft.com/office/drawing/2014/main" id="{B51300F2-440E-42AF-A121-AB48BE4B8304}"/>
               </a:ext>
             </a:extLst>
           </p:cNvPr>
@@ -6795,7 +6795,7 @@
           <p:cNvPr id="171" name="General Time-Series Harness-marker-16">
             <a:extLst xmlns:a="http://schemas.openxmlformats.org/drawingml/2006/main">
               <a:ext uri="{FF2B5EF4-FFF2-40B4-BE49-F238E27FC236}">
-                <a16:creationId xmlns:a16="http://schemas.microsoft.com/office/drawing/2014/main" id="{8C9A7A25-7C5F-4954-ADA2-456F86119481}"/>
+                <a16:creationId xmlns:a16="http://schemas.microsoft.com/office/drawing/2014/main" id="{AFFFC64B-2313-4F18-9D9A-7AF0B9B6C682}"/>
               </a:ext>
             </a:extLst>
           </p:cNvPr>
@@ -6828,7 +6828,7 @@
           <p:cNvPr id="172" name="General Time-Series Harness-marker-17">
             <a:extLst xmlns:a="http://schemas.openxmlformats.org/drawingml/2006/main">
               <a:ext uri="{FF2B5EF4-FFF2-40B4-BE49-F238E27FC236}">
-                <a16:creationId xmlns:a16="http://schemas.microsoft.com/office/drawing/2014/main" id="{7B7F2CB8-C72F-465F-B988-519646E88560}"/>
+                <a16:creationId xmlns:a16="http://schemas.microsoft.com/office/drawing/2014/main" id="{01560F4C-92D8-49F4-B5C8-A41FD5565629}"/>
               </a:ext>
             </a:extLst>
           </p:cNvPr>
@@ -6861,7 +6861,7 @@
           <p:cNvPr id="173" name="General Time-Series Harness-marker-18">
             <a:extLst xmlns:a="http://schemas.openxmlformats.org/drawingml/2006/main">
               <a:ext uri="{FF2B5EF4-FFF2-40B4-BE49-F238E27FC236}">
-                <a16:creationId xmlns:a16="http://schemas.microsoft.com/office/drawing/2014/main" id="{89FAE565-8E36-46C6-BAB3-1EBE1A55875E}"/>
+                <a16:creationId xmlns:a16="http://schemas.microsoft.com/office/drawing/2014/main" id="{183F9096-9D63-4F4F-9EA5-465AFE46B959}"/>
               </a:ext>
             </a:extLst>
           </p:cNvPr>
@@ -6894,7 +6894,7 @@
           <p:cNvPr id="174" name="General Time-Series Harness-marker-19">
             <a:extLst xmlns:a="http://schemas.openxmlformats.org/drawingml/2006/main">
               <a:ext uri="{FF2B5EF4-FFF2-40B4-BE49-F238E27FC236}">
-                <a16:creationId xmlns:a16="http://schemas.microsoft.com/office/drawing/2014/main" id="{028DEEC4-070A-42E1-866A-FD0A794D819A}"/>
+                <a16:creationId xmlns:a16="http://schemas.microsoft.com/office/drawing/2014/main" id="{7F9C2C10-8DC3-43ED-9EF7-173213D2BBDE}"/>
               </a:ext>
             </a:extLst>
           </p:cNvPr>
@@ -6927,7 +6927,7 @@
           <p:cNvPr id="175" name="General Time-Series Harness-marker-20">
             <a:extLst xmlns:a="http://schemas.openxmlformats.org/drawingml/2006/main">
               <a:ext uri="{FF2B5EF4-FFF2-40B4-BE49-F238E27FC236}">
-                <a16:creationId xmlns:a16="http://schemas.microsoft.com/office/drawing/2014/main" id="{48FE4F05-6227-4D73-8D23-EC065DFC4376}"/>
+                <a16:creationId xmlns:a16="http://schemas.microsoft.com/office/drawing/2014/main" id="{3BD064AD-61FD-44F7-A94E-98348316B602}"/>
               </a:ext>
             </a:extLst>
           </p:cNvPr>
@@ -6960,7 +6960,7 @@
           <p:cNvPr id="176" name="General Time-Series Harness-marker-21">
             <a:extLst xmlns:a="http://schemas.openxmlformats.org/drawingml/2006/main">
               <a:ext uri="{FF2B5EF4-FFF2-40B4-BE49-F238E27FC236}">
-                <a16:creationId xmlns:a16="http://schemas.microsoft.com/office/drawing/2014/main" id="{415A0BF7-451E-42EF-94C2-D314027E5DF5}"/>
+                <a16:creationId xmlns:a16="http://schemas.microsoft.com/office/drawing/2014/main" id="{048EA351-D0EE-46E1-B833-2D413E6DCC30}"/>
               </a:ext>
             </a:extLst>
           </p:cNvPr>
@@ -6993,7 +6993,7 @@
           <p:cNvPr id="177" name="General Time-Series Harness-marker-22">
             <a:extLst xmlns:a="http://schemas.openxmlformats.org/drawingml/2006/main">
               <a:ext uri="{FF2B5EF4-FFF2-40B4-BE49-F238E27FC236}">
-                <a16:creationId xmlns:a16="http://schemas.microsoft.com/office/drawing/2014/main" id="{816627D4-3872-49D8-AAB6-4BF7BAAD2FBA}"/>
+                <a16:creationId xmlns:a16="http://schemas.microsoft.com/office/drawing/2014/main" id="{6F66B311-A282-4B2A-8C89-3834B242A7B9}"/>
               </a:ext>
             </a:extLst>
           </p:cNvPr>
@@ -7026,7 +7026,7 @@
           <p:cNvPr id="178" name="General Time-Series Harness-marker-23">
             <a:extLst xmlns:a="http://schemas.openxmlformats.org/drawingml/2006/main">
               <a:ext uri="{FF2B5EF4-FFF2-40B4-BE49-F238E27FC236}">
-                <a16:creationId xmlns:a16="http://schemas.microsoft.com/office/drawing/2014/main" id="{A665BEB7-44E4-48AD-823F-AC4BC386C16F}"/>
+                <a16:creationId xmlns:a16="http://schemas.microsoft.com/office/drawing/2014/main" id="{E095BA66-0C3A-4D39-A3DC-047379E141DC}"/>
               </a:ext>
             </a:extLst>
           </p:cNvPr>
@@ -7059,7 +7059,7 @@
           <p:cNvPr id="179" name="General Time-Series Harness-marker-24">
             <a:extLst xmlns:a="http://schemas.openxmlformats.org/drawingml/2006/main">
               <a:ext uri="{FF2B5EF4-FFF2-40B4-BE49-F238E27FC236}">
-                <a16:creationId xmlns:a16="http://schemas.microsoft.com/office/drawing/2014/main" id="{271710E1-EFC0-4F40-AA47-FBAAB7A2F475}"/>
+                <a16:creationId xmlns:a16="http://schemas.microsoft.com/office/drawing/2014/main" id="{0786F388-9790-4D58-8560-BDF9A1E6C472}"/>
               </a:ext>
             </a:extLst>
           </p:cNvPr>
@@ -7092,7 +7092,7 @@
           <p:cNvPr id="180" name="General Time-Series Harness-marker-25">
             <a:extLst xmlns:a="http://schemas.openxmlformats.org/drawingml/2006/main">
               <a:ext uri="{FF2B5EF4-FFF2-40B4-BE49-F238E27FC236}">
-                <a16:creationId xmlns:a16="http://schemas.microsoft.com/office/drawing/2014/main" id="{9C460D31-1CCF-492F-A9D5-EEF0FCC3EE9A}"/>
+                <a16:creationId xmlns:a16="http://schemas.microsoft.com/office/drawing/2014/main" id="{CCAFE1BE-8A52-49A9-972F-BE7DC181E390}"/>
               </a:ext>
             </a:extLst>
           </p:cNvPr>
@@ -7125,7 +7125,7 @@
           <p:cNvPr id="181" name="General Time-Series Harness-marker-26">
             <a:extLst xmlns:a="http://schemas.openxmlformats.org/drawingml/2006/main">
               <a:ext uri="{FF2B5EF4-FFF2-40B4-BE49-F238E27FC236}">
-                <a16:creationId xmlns:a16="http://schemas.microsoft.com/office/drawing/2014/main" id="{2458CA7F-7A9B-487D-B99B-B6FECCDC3D7A}"/>
+                <a16:creationId xmlns:a16="http://schemas.microsoft.com/office/drawing/2014/main" id="{508D560A-7D3E-4B40-8445-41DB2E8BFBF6}"/>
               </a:ext>
             </a:extLst>
           </p:cNvPr>
@@ -7158,7 +7158,7 @@
           <p:cNvPr id="182" name="General Time-Series Harness-marker-27">
             <a:extLst xmlns:a="http://schemas.openxmlformats.org/drawingml/2006/main">
               <a:ext uri="{FF2B5EF4-FFF2-40B4-BE49-F238E27FC236}">
-                <a16:creationId xmlns:a16="http://schemas.microsoft.com/office/drawing/2014/main" id="{32498E69-8A96-4E41-AC82-687B434C5CDF}"/>
+                <a16:creationId xmlns:a16="http://schemas.microsoft.com/office/drawing/2014/main" id="{ED24BD51-9585-4445-9B53-ABA2B13C907F}"/>
               </a:ext>
             </a:extLst>
           </p:cNvPr>
@@ -7191,7 +7191,7 @@
           <p:cNvPr id="183" name="General Time-Series Harness-marker-28">
             <a:extLst xmlns:a="http://schemas.openxmlformats.org/drawingml/2006/main">
               <a:ext uri="{FF2B5EF4-FFF2-40B4-BE49-F238E27FC236}">
-                <a16:creationId xmlns:a16="http://schemas.microsoft.com/office/drawing/2014/main" id="{6DAC2CD7-365D-4FDE-89DA-9F7C24E1BF7B}"/>
+                <a16:creationId xmlns:a16="http://schemas.microsoft.com/office/drawing/2014/main" id="{55FA0D8A-8106-40D4-9681-EFB48E3951BB}"/>
               </a:ext>
             </a:extLst>
           </p:cNvPr>
@@ -7224,7 +7224,7 @@
           <p:cNvPr id="184" name="General Time-Series Harness-marker-29">
             <a:extLst xmlns:a="http://schemas.openxmlformats.org/drawingml/2006/main">
               <a:ext uri="{FF2B5EF4-FFF2-40B4-BE49-F238E27FC236}">
-                <a16:creationId xmlns:a16="http://schemas.microsoft.com/office/drawing/2014/main" id="{49685E04-3C47-41E2-AC03-44156BEEFAD3}"/>
+                <a16:creationId xmlns:a16="http://schemas.microsoft.com/office/drawing/2014/main" id="{C7A1CF6E-E73A-4E65-9689-9E84528AA400}"/>
               </a:ext>
             </a:extLst>
           </p:cNvPr>
@@ -7257,7 +7257,7 @@
           <p:cNvPr id="185" name="Task-Specific Harness-segment-1">
             <a:extLst xmlns:a="http://schemas.openxmlformats.org/drawingml/2006/main">
               <a:ext uri="{FF2B5EF4-FFF2-40B4-BE49-F238E27FC236}">
-                <a16:creationId xmlns:a16="http://schemas.microsoft.com/office/drawing/2014/main" id="{F47C373A-0074-410F-8B1D-785F9A79374D}"/>
+                <a16:creationId xmlns:a16="http://schemas.microsoft.com/office/drawing/2014/main" id="{05CADF4A-EFCA-4297-868B-2695E59EF49F}"/>
               </a:ext>
             </a:extLst>
           </p:cNvPr>
@@ -7288,7 +7288,7 @@
           <p:cNvPr id="186" name="Task-Specific Harness-segment-2">
             <a:extLst xmlns:a="http://schemas.openxmlformats.org/drawingml/2006/main">
               <a:ext uri="{FF2B5EF4-FFF2-40B4-BE49-F238E27FC236}">
-                <a16:creationId xmlns:a16="http://schemas.microsoft.com/office/drawing/2014/main" id="{2D3B215D-67E5-4B3C-ADA4-3EB2B7F3B601}"/>
+                <a16:creationId xmlns:a16="http://schemas.microsoft.com/office/drawing/2014/main" id="{79B53945-872F-4ED7-B470-0B0684F89CFF}"/>
               </a:ext>
             </a:extLst>
           </p:cNvPr>
@@ -7319,7 +7319,7 @@
           <p:cNvPr id="187" name="Task-Specific Harness-segment-3">
             <a:extLst xmlns:a="http://schemas.openxmlformats.org/drawingml/2006/main">
               <a:ext uri="{FF2B5EF4-FFF2-40B4-BE49-F238E27FC236}">
-                <a16:creationId xmlns:a16="http://schemas.microsoft.com/office/drawing/2014/main" id="{3B3539EF-3244-4076-A879-C9A951701291}"/>
+                <a16:creationId xmlns:a16="http://schemas.microsoft.com/office/drawing/2014/main" id="{54216EDC-F664-4153-A976-A309ED2A6444}"/>
               </a:ext>
             </a:extLst>
           </p:cNvPr>
@@ -7350,7 +7350,7 @@
           <p:cNvPr id="188" name="Task-Specific Harness-segment-4">
             <a:extLst xmlns:a="http://schemas.openxmlformats.org/drawingml/2006/main">
               <a:ext uri="{FF2B5EF4-FFF2-40B4-BE49-F238E27FC236}">
-                <a16:creationId xmlns:a16="http://schemas.microsoft.com/office/drawing/2014/main" id="{A809EFA3-AB1E-4458-8FF6-47363B0022A1}"/>
+                <a16:creationId xmlns:a16="http://schemas.microsoft.com/office/drawing/2014/main" id="{894834F6-2842-402B-A824-3964A9947CDC}"/>
               </a:ext>
             </a:extLst>
           </p:cNvPr>
@@ -7381,7 +7381,7 @@
           <p:cNvPr id="189" name="Task-Specific Harness-segment-5">
             <a:extLst xmlns:a="http://schemas.openxmlformats.org/drawingml/2006/main">
               <a:ext uri="{FF2B5EF4-FFF2-40B4-BE49-F238E27FC236}">
-                <a16:creationId xmlns:a16="http://schemas.microsoft.com/office/drawing/2014/main" id="{24E409B3-B2AA-4A78-8576-AFF7DDCA0A56}"/>
+                <a16:creationId xmlns:a16="http://schemas.microsoft.com/office/drawing/2014/main" id="{C6E3BBB2-A0C4-482F-82F2-891391E7C021}"/>
               </a:ext>
             </a:extLst>
           </p:cNvPr>
@@ -7412,7 +7412,7 @@
           <p:cNvPr id="190" name="Task-Specific Harness-segment-6">
             <a:extLst xmlns:a="http://schemas.openxmlformats.org/drawingml/2006/main">
               <a:ext uri="{FF2B5EF4-FFF2-40B4-BE49-F238E27FC236}">
-                <a16:creationId xmlns:a16="http://schemas.microsoft.com/office/drawing/2014/main" id="{70C2C79E-7E94-4E2E-AB23-835BD49B7047}"/>
+                <a16:creationId xmlns:a16="http://schemas.microsoft.com/office/drawing/2014/main" id="{7EDE6CF1-83D5-457F-82C4-EE09FE7D0B76}"/>
               </a:ext>
             </a:extLst>
           </p:cNvPr>
@@ -7443,7 +7443,7 @@
           <p:cNvPr id="191" name="Task-Specific Harness-segment-7">
             <a:extLst xmlns:a="http://schemas.openxmlformats.org/drawingml/2006/main">
               <a:ext uri="{FF2B5EF4-FFF2-40B4-BE49-F238E27FC236}">
-                <a16:creationId xmlns:a16="http://schemas.microsoft.com/office/drawing/2014/main" id="{7DD964EF-A858-4CB2-B2DA-394EC56A0E63}"/>
+                <a16:creationId xmlns:a16="http://schemas.microsoft.com/office/drawing/2014/main" id="{E9969BD5-2D1B-4664-8ACC-A476C0FBE030}"/>
               </a:ext>
             </a:extLst>
           </p:cNvPr>
@@ -7474,7 +7474,7 @@
           <p:cNvPr id="192" name="Task-Specific Harness-segment-8">
             <a:extLst xmlns:a="http://schemas.openxmlformats.org/drawingml/2006/main">
               <a:ext uri="{FF2B5EF4-FFF2-40B4-BE49-F238E27FC236}">
-                <a16:creationId xmlns:a16="http://schemas.microsoft.com/office/drawing/2014/main" id="{15646AD0-0072-4253-BB3F-09B715AEAE2F}"/>
+                <a16:creationId xmlns:a16="http://schemas.microsoft.com/office/drawing/2014/main" id="{EB436C0F-7BC1-420A-A9EE-1A08A55E46B6}"/>
               </a:ext>
             </a:extLst>
           </p:cNvPr>
@@ -7505,7 +7505,7 @@
           <p:cNvPr id="193" name="Task-Specific Harness-segment-9">
             <a:extLst xmlns:a="http://schemas.openxmlformats.org/drawingml/2006/main">
               <a:ext uri="{FF2B5EF4-FFF2-40B4-BE49-F238E27FC236}">
-                <a16:creationId xmlns:a16="http://schemas.microsoft.com/office/drawing/2014/main" id="{C46B8890-DE74-4CA9-B12F-B294F75C8295}"/>
+                <a16:creationId xmlns:a16="http://schemas.microsoft.com/office/drawing/2014/main" id="{1842634C-A7E8-476C-A1C1-6D1F8991084A}"/>
               </a:ext>
             </a:extLst>
           </p:cNvPr>
@@ -7536,7 +7536,7 @@
           <p:cNvPr id="194" name="Task-Specific Harness-segment-10">
             <a:extLst xmlns:a="http://schemas.openxmlformats.org/drawingml/2006/main">
               <a:ext uri="{FF2B5EF4-FFF2-40B4-BE49-F238E27FC236}">
-                <a16:creationId xmlns:a16="http://schemas.microsoft.com/office/drawing/2014/main" id="{84EDF94E-FDFC-4E72-837D-591B42746D2E}"/>
+                <a16:creationId xmlns:a16="http://schemas.microsoft.com/office/drawing/2014/main" id="{4F3E42F9-5C2A-43DF-96A6-9C0ED418BDB9}"/>
               </a:ext>
             </a:extLst>
           </p:cNvPr>
@@ -7567,7 +7567,7 @@
           <p:cNvPr id="195" name="Task-Specific Harness-segment-11">
             <a:extLst xmlns:a="http://schemas.openxmlformats.org/drawingml/2006/main">
               <a:ext uri="{FF2B5EF4-FFF2-40B4-BE49-F238E27FC236}">
-                <a16:creationId xmlns:a16="http://schemas.microsoft.com/office/drawing/2014/main" id="{CABE8256-D81E-493A-9D3E-4A0D32416CC5}"/>
+                <a16:creationId xmlns:a16="http://schemas.microsoft.com/office/drawing/2014/main" id="{4B231BD9-0812-47AB-B437-3111BFD4B24A}"/>
               </a:ext>
             </a:extLst>
           </p:cNvPr>
@@ -7598,7 +7598,7 @@
           <p:cNvPr id="196" name="Task-Specific Harness-segment-12">
             <a:extLst xmlns:a="http://schemas.openxmlformats.org/drawingml/2006/main">
               <a:ext uri="{FF2B5EF4-FFF2-40B4-BE49-F238E27FC236}">
-                <a16:creationId xmlns:a16="http://schemas.microsoft.com/office/drawing/2014/main" id="{00B7C09A-5EE5-4C0B-8784-9C84DF51B097}"/>
+                <a16:creationId xmlns:a16="http://schemas.microsoft.com/office/drawing/2014/main" id="{18500BAB-A495-4484-8FBF-03F5737B521D}"/>
               </a:ext>
             </a:extLst>
           </p:cNvPr>
@@ -7629,7 +7629,7 @@
           <p:cNvPr id="197" name="Task-Specific Harness-segment-13">
             <a:extLst xmlns:a="http://schemas.openxmlformats.org/drawingml/2006/main">
               <a:ext uri="{FF2B5EF4-FFF2-40B4-BE49-F238E27FC236}">
-                <a16:creationId xmlns:a16="http://schemas.microsoft.com/office/drawing/2014/main" id="{7FF7196C-A865-4851-8B9B-604E87AAA59C}"/>
+                <a16:creationId xmlns:a16="http://schemas.microsoft.com/office/drawing/2014/main" id="{8254592B-6754-4E89-BEB9-A2FB1E0329BF}"/>
               </a:ext>
             </a:extLst>
           </p:cNvPr>
@@ -7660,7 +7660,7 @@
           <p:cNvPr id="198" name="Task-Specific Harness-segment-14">
             <a:extLst xmlns:a="http://schemas.openxmlformats.org/drawingml/2006/main">
               <a:ext uri="{FF2B5EF4-FFF2-40B4-BE49-F238E27FC236}">
-                <a16:creationId xmlns:a16="http://schemas.microsoft.com/office/drawing/2014/main" id="{7DB12991-110A-45C4-B1C4-EDFF78E319BE}"/>
+                <a16:creationId xmlns:a16="http://schemas.microsoft.com/office/drawing/2014/main" id="{477FCB14-4F4F-4A64-99B4-332E17710D82}"/>
               </a:ext>
             </a:extLst>
           </p:cNvPr>
@@ -7691,7 +7691,7 @@
           <p:cNvPr id="199" name="Task-Specific Harness-segment-15">
             <a:extLst xmlns:a="http://schemas.openxmlformats.org/drawingml/2006/main">
               <a:ext uri="{FF2B5EF4-FFF2-40B4-BE49-F238E27FC236}">
-                <a16:creationId xmlns:a16="http://schemas.microsoft.com/office/drawing/2014/main" id="{1BCB877A-A551-4A8D-AF1D-B5DD9BDAB0CA}"/>
+                <a16:creationId xmlns:a16="http://schemas.microsoft.com/office/drawing/2014/main" id="{DB560F0B-1E32-46A7-B729-36C3C3056DBD}"/>
               </a:ext>
             </a:extLst>
           </p:cNvPr>
@@ -7722,7 +7722,7 @@
           <p:cNvPr id="200" name="Task-Specific Harness-segment-16">
             <a:extLst xmlns:a="http://schemas.openxmlformats.org/drawingml/2006/main">
               <a:ext uri="{FF2B5EF4-FFF2-40B4-BE49-F238E27FC236}">
-                <a16:creationId xmlns:a16="http://schemas.microsoft.com/office/drawing/2014/main" id="{E32B3A5A-2027-4D25-A61B-94C7FC5AD887}"/>
+                <a16:creationId xmlns:a16="http://schemas.microsoft.com/office/drawing/2014/main" id="{3BF057A9-C6B5-45CC-8519-DBD7832DAB7D}"/>
               </a:ext>
             </a:extLst>
           </p:cNvPr>
@@ -7753,7 +7753,7 @@
           <p:cNvPr id="201" name="Task-Specific Harness-segment-17">
             <a:extLst xmlns:a="http://schemas.openxmlformats.org/drawingml/2006/main">
               <a:ext uri="{FF2B5EF4-FFF2-40B4-BE49-F238E27FC236}">
-                <a16:creationId xmlns:a16="http://schemas.microsoft.com/office/drawing/2014/main" id="{2A754F42-9490-40CB-8725-FF2198FE117D}"/>
+                <a16:creationId xmlns:a16="http://schemas.microsoft.com/office/drawing/2014/main" id="{0E087B45-6D3B-4184-9061-F14E1E24CD85}"/>
               </a:ext>
             </a:extLst>
           </p:cNvPr>
@@ -7784,7 +7784,7 @@
           <p:cNvPr id="202" name="Task-Specific Harness-segment-18">
             <a:extLst xmlns:a="http://schemas.openxmlformats.org/drawingml/2006/main">
               <a:ext uri="{FF2B5EF4-FFF2-40B4-BE49-F238E27FC236}">
-                <a16:creationId xmlns:a16="http://schemas.microsoft.com/office/drawing/2014/main" id="{CF68C8AE-B604-4AFC-AB92-CAE0A97601CD}"/>
+                <a16:creationId xmlns:a16="http://schemas.microsoft.com/office/drawing/2014/main" id="{4649AB72-4A4C-4107-AFFF-299DB139D124}"/>
               </a:ext>
             </a:extLst>
           </p:cNvPr>
@@ -7815,7 +7815,7 @@
           <p:cNvPr id="203" name="Task-Specific Harness-segment-19">
             <a:extLst xmlns:a="http://schemas.openxmlformats.org/drawingml/2006/main">
               <a:ext uri="{FF2B5EF4-FFF2-40B4-BE49-F238E27FC236}">
-                <a16:creationId xmlns:a16="http://schemas.microsoft.com/office/drawing/2014/main" id="{153D9AD4-386D-4DC6-BDDB-DCFE8D5C2DB2}"/>
+                <a16:creationId xmlns:a16="http://schemas.microsoft.com/office/drawing/2014/main" id="{28039572-05B1-48D1-8B0E-02225F883C30}"/>
               </a:ext>
             </a:extLst>
           </p:cNvPr>
@@ -7846,7 +7846,7 @@
           <p:cNvPr id="204" name="Task-Specific Harness-segment-20">
             <a:extLst xmlns:a="http://schemas.openxmlformats.org/drawingml/2006/main">
               <a:ext uri="{FF2B5EF4-FFF2-40B4-BE49-F238E27FC236}">
-                <a16:creationId xmlns:a16="http://schemas.microsoft.com/office/drawing/2014/main" id="{83B6DD2A-5ED8-4E1C-9357-E72EAA3A8AE7}"/>
+                <a16:creationId xmlns:a16="http://schemas.microsoft.com/office/drawing/2014/main" id="{818B0C72-CB8F-4C7E-B78B-B34B4888F4A6}"/>
               </a:ext>
             </a:extLst>
           </p:cNvPr>
@@ -7877,7 +7877,7 @@
           <p:cNvPr id="205" name="Task-Specific Harness-segment-21">
             <a:extLst xmlns:a="http://schemas.openxmlformats.org/drawingml/2006/main">
               <a:ext uri="{FF2B5EF4-FFF2-40B4-BE49-F238E27FC236}">
-                <a16:creationId xmlns:a16="http://schemas.microsoft.com/office/drawing/2014/main" id="{AD43968C-8A8C-4C34-9B6E-F7FB5C9A1CBB}"/>
+                <a16:creationId xmlns:a16="http://schemas.microsoft.com/office/drawing/2014/main" id="{912CBF45-ADD0-4C6F-B03B-0ED35912F3FE}"/>
               </a:ext>
             </a:extLst>
           </p:cNvPr>
@@ -7908,7 +7908,7 @@
           <p:cNvPr id="206" name="Task-Specific Harness-segment-22">
             <a:extLst xmlns:a="http://schemas.openxmlformats.org/drawingml/2006/main">
               <a:ext uri="{FF2B5EF4-FFF2-40B4-BE49-F238E27FC236}">
-                <a16:creationId xmlns:a16="http://schemas.microsoft.com/office/drawing/2014/main" id="{5EE7BB46-3621-40E5-A8A6-39A2F82D8409}"/>
+                <a16:creationId xmlns:a16="http://schemas.microsoft.com/office/drawing/2014/main" id="{25702041-EFFE-4140-82F5-F5E725512E5A}"/>
               </a:ext>
             </a:extLst>
           </p:cNvPr>
@@ -7939,7 +7939,7 @@
           <p:cNvPr id="207" name="Task-Specific Harness-segment-23">
             <a:extLst xmlns:a="http://schemas.openxmlformats.org/drawingml/2006/main">
               <a:ext uri="{FF2B5EF4-FFF2-40B4-BE49-F238E27FC236}">
-                <a16:creationId xmlns:a16="http://schemas.microsoft.com/office/drawing/2014/main" id="{D9CF977F-1BF9-469B-896F-890B56C4E943}"/>
+                <a16:creationId xmlns:a16="http://schemas.microsoft.com/office/drawing/2014/main" id="{65CF02D5-3A8C-40AF-9323-89771F2AE21A}"/>
               </a:ext>
             </a:extLst>
           </p:cNvPr>
@@ -7970,7 +7970,7 @@
           <p:cNvPr id="208" name="Task-Specific Harness-segment-24">
             <a:extLst xmlns:a="http://schemas.openxmlformats.org/drawingml/2006/main">
               <a:ext uri="{FF2B5EF4-FFF2-40B4-BE49-F238E27FC236}">
-                <a16:creationId xmlns:a16="http://schemas.microsoft.com/office/drawing/2014/main" id="{9FF84155-67C6-4BEF-A140-1091CB8C8628}"/>
+                <a16:creationId xmlns:a16="http://schemas.microsoft.com/office/drawing/2014/main" id="{AB2FA163-94E1-41A0-8E1F-71A846A3521C}"/>
               </a:ext>
             </a:extLst>
           </p:cNvPr>
@@ -8001,7 +8001,7 @@
           <p:cNvPr id="209" name="Task-Specific Harness-segment-25">
             <a:extLst xmlns:a="http://schemas.openxmlformats.org/drawingml/2006/main">
               <a:ext uri="{FF2B5EF4-FFF2-40B4-BE49-F238E27FC236}">
-                <a16:creationId xmlns:a16="http://schemas.microsoft.com/office/drawing/2014/main" id="{59F6C391-B956-4E0F-8AA7-28A7611BD17C}"/>
+                <a16:creationId xmlns:a16="http://schemas.microsoft.com/office/drawing/2014/main" id="{12D94312-A992-4AFF-BFEC-3D06F8588583}"/>
               </a:ext>
             </a:extLst>
           </p:cNvPr>
@@ -8032,7 +8032,7 @@
           <p:cNvPr id="210" name="Task-Specific Harness-segment-26">
             <a:extLst xmlns:a="http://schemas.openxmlformats.org/drawingml/2006/main">
               <a:ext uri="{FF2B5EF4-FFF2-40B4-BE49-F238E27FC236}">
-                <a16:creationId xmlns:a16="http://schemas.microsoft.com/office/drawing/2014/main" id="{820C9FA3-483C-4DE8-B86F-6ACA8EC65937}"/>
+                <a16:creationId xmlns:a16="http://schemas.microsoft.com/office/drawing/2014/main" id="{377E3FA1-5967-4727-90BD-2252D8A2AE4C}"/>
               </a:ext>
             </a:extLst>
           </p:cNvPr>
@@ -8063,7 +8063,7 @@
           <p:cNvPr id="211" name="Task-Specific Harness-segment-27">
             <a:extLst xmlns:a="http://schemas.openxmlformats.org/drawingml/2006/main">
               <a:ext uri="{FF2B5EF4-FFF2-40B4-BE49-F238E27FC236}">
-                <a16:creationId xmlns:a16="http://schemas.microsoft.com/office/drawing/2014/main" id="{8E713854-2A9B-486B-AEE2-02B27DE5EBE9}"/>
+                <a16:creationId xmlns:a16="http://schemas.microsoft.com/office/drawing/2014/main" id="{6CC591DF-82CE-4E31-91BA-92A6B01FD68D}"/>
               </a:ext>
             </a:extLst>
           </p:cNvPr>
@@ -8094,7 +8094,7 @@
           <p:cNvPr id="212" name="Task-Specific Harness-segment-28">
             <a:extLst xmlns:a="http://schemas.openxmlformats.org/drawingml/2006/main">
               <a:ext uri="{FF2B5EF4-FFF2-40B4-BE49-F238E27FC236}">
-                <a16:creationId xmlns:a16="http://schemas.microsoft.com/office/drawing/2014/main" id="{F9004D1F-1490-4C0E-9465-87D14522AE1F}"/>
+                <a16:creationId xmlns:a16="http://schemas.microsoft.com/office/drawing/2014/main" id="{8E2F7275-0D5A-4CF6-919E-DB9ADE1FBE3F}"/>
               </a:ext>
             </a:extLst>
           </p:cNvPr>
@@ -8125,7 +8125,7 @@
           <p:cNvPr id="213" name="Task-Specific Harness-segment-29">
             <a:extLst xmlns:a="http://schemas.openxmlformats.org/drawingml/2006/main">
               <a:ext uri="{FF2B5EF4-FFF2-40B4-BE49-F238E27FC236}">
-                <a16:creationId xmlns:a16="http://schemas.microsoft.com/office/drawing/2014/main" id="{76094708-3A3B-4FA9-A133-99DDFF304D98}"/>
+                <a16:creationId xmlns:a16="http://schemas.microsoft.com/office/drawing/2014/main" id="{D48FF52C-9287-4C16-BF08-88311D59A25E}"/>
               </a:ext>
             </a:extLst>
           </p:cNvPr>
@@ -8156,7 +8156,7 @@
           <p:cNvPr id="214" name="Task-Specific Harness-marker-0">
             <a:extLst xmlns:a="http://schemas.openxmlformats.org/drawingml/2006/main">
               <a:ext uri="{FF2B5EF4-FFF2-40B4-BE49-F238E27FC236}">
-                <a16:creationId xmlns:a16="http://schemas.microsoft.com/office/drawing/2014/main" id="{10B70840-3368-4155-B1FB-FE5F74CBA1C9}"/>
+                <a16:creationId xmlns:a16="http://schemas.microsoft.com/office/drawing/2014/main" id="{8D4EBB97-95BB-4352-BE06-D77A536A5A99}"/>
               </a:ext>
             </a:extLst>
           </p:cNvPr>
@@ -8189,7 +8189,7 @@
           <p:cNvPr id="215" name="Task-Specific Harness-marker-1">
             <a:extLst xmlns:a="http://schemas.openxmlformats.org/drawingml/2006/main">
               <a:ext uri="{FF2B5EF4-FFF2-40B4-BE49-F238E27FC236}">
-                <a16:creationId xmlns:a16="http://schemas.microsoft.com/office/drawing/2014/main" id="{946FE67F-053E-49F0-A88F-498A6820D219}"/>
+                <a16:creationId xmlns:a16="http://schemas.microsoft.com/office/drawing/2014/main" id="{B3C930A3-0087-4E4E-9B52-03D67CBF926C}"/>
               </a:ext>
             </a:extLst>
           </p:cNvPr>
@@ -8222,7 +8222,7 @@
           <p:cNvPr id="216" name="Task-Specific Harness-marker-2">
             <a:extLst xmlns:a="http://schemas.openxmlformats.org/drawingml/2006/main">
               <a:ext uri="{FF2B5EF4-FFF2-40B4-BE49-F238E27FC236}">
-                <a16:creationId xmlns:a16="http://schemas.microsoft.com/office/drawing/2014/main" id="{634738A7-7BD0-48A3-B233-EF1F9A54DE88}"/>
+                <a16:creationId xmlns:a16="http://schemas.microsoft.com/office/drawing/2014/main" id="{96A119BD-BEBA-4E4C-88DC-E3AA74FE22CC}"/>
               </a:ext>
             </a:extLst>
           </p:cNvPr>
@@ -8255,7 +8255,7 @@
           <p:cNvPr id="217" name="Task-Specific Harness-marker-3">
             <a:extLst xmlns:a="http://schemas.openxmlformats.org/drawingml/2006/main">
               <a:ext uri="{FF2B5EF4-FFF2-40B4-BE49-F238E27FC236}">
-                <a16:creationId xmlns:a16="http://schemas.microsoft.com/office/drawing/2014/main" id="{7F6C8400-4511-4C12-A198-114D17E838E8}"/>
+                <a16:creationId xmlns:a16="http://schemas.microsoft.com/office/drawing/2014/main" id="{48226F2C-DF42-4099-84B8-7AC5AA62D1A8}"/>
               </a:ext>
             </a:extLst>
           </p:cNvPr>
@@ -8288,7 +8288,7 @@
           <p:cNvPr id="218" name="Task-Specific Harness-marker-4">
             <a:extLst xmlns:a="http://schemas.openxmlformats.org/drawingml/2006/main">
               <a:ext uri="{FF2B5EF4-FFF2-40B4-BE49-F238E27FC236}">
-                <a16:creationId xmlns:a16="http://schemas.microsoft.com/office/drawing/2014/main" id="{34239499-3367-41B4-9D18-977DA81BBF0D}"/>
+                <a16:creationId xmlns:a16="http://schemas.microsoft.com/office/drawing/2014/main" id="{C6AEA7D1-5286-4DAF-93FC-25651A67FEC7}"/>
               </a:ext>
             </a:extLst>
           </p:cNvPr>
@@ -8321,7 +8321,7 @@
           <p:cNvPr id="219" name="Task-Specific Harness-marker-5">
             <a:extLst xmlns:a="http://schemas.openxmlformats.org/drawingml/2006/main">
               <a:ext uri="{FF2B5EF4-FFF2-40B4-BE49-F238E27FC236}">
-                <a16:creationId xmlns:a16="http://schemas.microsoft.com/office/drawing/2014/main" id="{8C21A11F-D628-49F6-9B78-33BFBF4B1320}"/>
+                <a16:creationId xmlns:a16="http://schemas.microsoft.com/office/drawing/2014/main" id="{9A560296-BD19-4DFC-BA0A-6392C83A5BBA}"/>
               </a:ext>
             </a:extLst>
           </p:cNvPr>
@@ -8354,7 +8354,7 @@
           <p:cNvPr id="220" name="Task-Specific Harness-marker-6">
             <a:extLst xmlns:a="http://schemas.openxmlformats.org/drawingml/2006/main">
               <a:ext uri="{FF2B5EF4-FFF2-40B4-BE49-F238E27FC236}">
-                <a16:creationId xmlns:a16="http://schemas.microsoft.com/office/drawing/2014/main" id="{B60D8DC7-E1FE-4172-96AA-0A3E2E0AACDA}"/>
+                <a16:creationId xmlns:a16="http://schemas.microsoft.com/office/drawing/2014/main" id="{AC6639B1-0298-4855-A075-40359D9976E9}"/>
               </a:ext>
             </a:extLst>
           </p:cNvPr>
@@ -8387,7 +8387,7 @@
           <p:cNvPr id="221" name="Task-Specific Harness-marker-7">
             <a:extLst xmlns:a="http://schemas.openxmlformats.org/drawingml/2006/main">
               <a:ext uri="{FF2B5EF4-FFF2-40B4-BE49-F238E27FC236}">
-                <a16:creationId xmlns:a16="http://schemas.microsoft.com/office/drawing/2014/main" id="{21DD90CC-9CBC-43AA-B9AE-FCE6C0B8D341}"/>
+                <a16:creationId xmlns:a16="http://schemas.microsoft.com/office/drawing/2014/main" id="{A87DFDA1-A58C-4A88-A484-AC740884E183}"/>
               </a:ext>
             </a:extLst>
           </p:cNvPr>
@@ -8420,7 +8420,7 @@
           <p:cNvPr id="222" name="Task-Specific Harness-marker-8">
             <a:extLst xmlns:a="http://schemas.openxmlformats.org/drawingml/2006/main">
               <a:ext uri="{FF2B5EF4-FFF2-40B4-BE49-F238E27FC236}">
-                <a16:creationId xmlns:a16="http://schemas.microsoft.com/office/drawing/2014/main" id="{223BB823-0355-4450-B4E3-7F519587ED6E}"/>
+                <a16:creationId xmlns:a16="http://schemas.microsoft.com/office/drawing/2014/main" id="{5F81C677-E6DA-4C3D-8837-3F823BA385CB}"/>
               </a:ext>
             </a:extLst>
           </p:cNvPr>
@@ -8453,7 +8453,7 @@
           <p:cNvPr id="223" name="Task-Specific Harness-marker-9">
             <a:extLst xmlns:a="http://schemas.openxmlformats.org/drawingml/2006/main">
               <a:ext uri="{FF2B5EF4-FFF2-40B4-BE49-F238E27FC236}">
-                <a16:creationId xmlns:a16="http://schemas.microsoft.com/office/drawing/2014/main" id="{5AEC76F0-933C-4378-A106-3E1739F0C354}"/>
+                <a16:creationId xmlns:a16="http://schemas.microsoft.com/office/drawing/2014/main" id="{04F15746-8ED9-4A98-8810-58653516847E}"/>
               </a:ext>
             </a:extLst>
           </p:cNvPr>
@@ -8486,7 +8486,7 @@
           <p:cNvPr id="224" name="Task-Specific Harness-marker-10">
             <a:extLst xmlns:a="http://schemas.openxmlformats.org/drawingml/2006/main">
               <a:ext uri="{FF2B5EF4-FFF2-40B4-BE49-F238E27FC236}">
-                <a16:creationId xmlns:a16="http://schemas.microsoft.com/office/drawing/2014/main" id="{20BFCB2A-14C0-495F-87C8-6FA332CA991B}"/>
+                <a16:creationId xmlns:a16="http://schemas.microsoft.com/office/drawing/2014/main" id="{23FF1528-9315-4749-BCDD-F8FF5E863D7C}"/>
               </a:ext>
             </a:extLst>
           </p:cNvPr>
@@ -8519,7 +8519,7 @@
           <p:cNvPr id="225" name="Task-Specific Harness-marker-11">
             <a:extLst xmlns:a="http://schemas.openxmlformats.org/drawingml/2006/main">
               <a:ext uri="{FF2B5EF4-FFF2-40B4-BE49-F238E27FC236}">
-                <a16:creationId xmlns:a16="http://schemas.microsoft.com/office/drawing/2014/main" id="{A215EA11-68E1-4EB1-876D-E39074645370}"/>
+                <a16:creationId xmlns:a16="http://schemas.microsoft.com/office/drawing/2014/main" id="{F30FF222-2022-4972-BC46-F7BD59216B44}"/>
               </a:ext>
             </a:extLst>
           </p:cNvPr>
@@ -8552,7 +8552,7 @@
           <p:cNvPr id="226" name="Task-Specific Harness-marker-12">
             <a:extLst xmlns:a="http://schemas.openxmlformats.org/drawingml/2006/main">
               <a:ext uri="{FF2B5EF4-FFF2-40B4-BE49-F238E27FC236}">
-                <a16:creationId xmlns:a16="http://schemas.microsoft.com/office/drawing/2014/main" id="{DF709936-A687-4717-B752-D00248E6FD5C}"/>
+                <a16:creationId xmlns:a16="http://schemas.microsoft.com/office/drawing/2014/main" id="{662A26A4-D62F-4584-81BE-C1711E4F1899}"/>
               </a:ext>
             </a:extLst>
           </p:cNvPr>
@@ -8585,7 +8585,7 @@
           <p:cNvPr id="227" name="Task-Specific Harness-marker-13">
             <a:extLst xmlns:a="http://schemas.openxmlformats.org/drawingml/2006/main">
               <a:ext uri="{FF2B5EF4-FFF2-40B4-BE49-F238E27FC236}">
-                <a16:creationId xmlns:a16="http://schemas.microsoft.com/office/drawing/2014/main" id="{A6B08600-120F-41BE-8C40-FC6AF3155137}"/>
+                <a16:creationId xmlns:a16="http://schemas.microsoft.com/office/drawing/2014/main" id="{5F9821A2-5C66-4D18-AE22-A07B3E358C59}"/>
               </a:ext>
             </a:extLst>
           </p:cNvPr>
@@ -8618,7 +8618,7 @@
           <p:cNvPr id="228" name="Task-Specific Harness-marker-14">
             <a:extLst xmlns:a="http://schemas.openxmlformats.org/drawingml/2006/main">
               <a:ext uri="{FF2B5EF4-FFF2-40B4-BE49-F238E27FC236}">
-                <a16:creationId xmlns:a16="http://schemas.microsoft.com/office/drawing/2014/main" id="{E63E9D75-D4E4-4DC9-AF68-2C064730BFDB}"/>
+                <a16:creationId xmlns:a16="http://schemas.microsoft.com/office/drawing/2014/main" id="{26934705-BF8A-4713-8FFC-8706947F2DDA}"/>
               </a:ext>
             </a:extLst>
           </p:cNvPr>
@@ -8651,7 +8651,7 @@
           <p:cNvPr id="229" name="Task-Specific Harness-marker-15">
             <a:extLst xmlns:a="http://schemas.openxmlformats.org/drawingml/2006/main">
               <a:ext uri="{FF2B5EF4-FFF2-40B4-BE49-F238E27FC236}">
-                <a16:creationId xmlns:a16="http://schemas.microsoft.com/office/drawing/2014/main" id="{84FE3D0B-51A2-498D-9DC9-F9E556AEB85D}"/>
+                <a16:creationId xmlns:a16="http://schemas.microsoft.com/office/drawing/2014/main" id="{067CF7E1-C501-4085-8BB4-6A706DCFA366}"/>
               </a:ext>
             </a:extLst>
           </p:cNvPr>
@@ -8684,7 +8684,7 @@
           <p:cNvPr id="230" name="Task-Specific Harness-marker-16">
             <a:extLst xmlns:a="http://schemas.openxmlformats.org/drawingml/2006/main">
               <a:ext uri="{FF2B5EF4-FFF2-40B4-BE49-F238E27FC236}">
-                <a16:creationId xmlns:a16="http://schemas.microsoft.com/office/drawing/2014/main" id="{B20AD7E2-E32B-4064-83DA-27FF8A213CC1}"/>
+                <a16:creationId xmlns:a16="http://schemas.microsoft.com/office/drawing/2014/main" id="{6369CCA4-7BAD-4B12-ADDB-4084C8E54E83}"/>
               </a:ext>
             </a:extLst>
           </p:cNvPr>
@@ -8717,7 +8717,7 @@
           <p:cNvPr id="231" name="Task-Specific Harness-marker-17">
             <a:extLst xmlns:a="http://schemas.openxmlformats.org/drawingml/2006/main">
               <a:ext uri="{FF2B5EF4-FFF2-40B4-BE49-F238E27FC236}">
-                <a16:creationId xmlns:a16="http://schemas.microsoft.com/office/drawing/2014/main" id="{169EE5C7-9667-4E3F-8D0E-0DB683F67263}"/>
+                <a16:creationId xmlns:a16="http://schemas.microsoft.com/office/drawing/2014/main" id="{EF0DB283-FFDB-44E9-B6C5-13758628477D}"/>
               </a:ext>
             </a:extLst>
           </p:cNvPr>
@@ -8750,7 +8750,7 @@
           <p:cNvPr id="232" name="Task-Specific Harness-marker-18">
             <a:extLst xmlns:a="http://schemas.openxmlformats.org/drawingml/2006/main">
               <a:ext uri="{FF2B5EF4-FFF2-40B4-BE49-F238E27FC236}">
-                <a16:creationId xmlns:a16="http://schemas.microsoft.com/office/drawing/2014/main" id="{64FE9C5D-5CD1-4C25-85F0-E935594A30CF}"/>
+                <a16:creationId xmlns:a16="http://schemas.microsoft.com/office/drawing/2014/main" id="{51D2DDB3-048A-4D44-88C0-8628D590DC76}"/>
               </a:ext>
             </a:extLst>
           </p:cNvPr>
@@ -8783,7 +8783,7 @@
           <p:cNvPr id="233" name="Task-Specific Harness-marker-19">
             <a:extLst xmlns:a="http://schemas.openxmlformats.org/drawingml/2006/main">
               <a:ext uri="{FF2B5EF4-FFF2-40B4-BE49-F238E27FC236}">
-                <a16:creationId xmlns:a16="http://schemas.microsoft.com/office/drawing/2014/main" id="{CE14627F-66C3-4569-95AE-7473A1D58953}"/>
+                <a16:creationId xmlns:a16="http://schemas.microsoft.com/office/drawing/2014/main" id="{CA60F14C-A4F3-4E42-8EFE-9EA1051E90D3}"/>
               </a:ext>
             </a:extLst>
           </p:cNvPr>
@@ -8816,7 +8816,7 @@
           <p:cNvPr id="234" name="Task-Specific Harness-marker-20">
             <a:extLst xmlns:a="http://schemas.openxmlformats.org/drawingml/2006/main">
               <a:ext uri="{FF2B5EF4-FFF2-40B4-BE49-F238E27FC236}">
-                <a16:creationId xmlns:a16="http://schemas.microsoft.com/office/drawing/2014/main" id="{D21BF36B-3393-40C1-83A8-68C69C3B4A0D}"/>
+                <a16:creationId xmlns:a16="http://schemas.microsoft.com/office/drawing/2014/main" id="{D9C5973C-EBC7-4BA2-8010-86C149AE0859}"/>
               </a:ext>
             </a:extLst>
           </p:cNvPr>
@@ -8849,7 +8849,7 @@
           <p:cNvPr id="235" name="Task-Specific Harness-marker-21">
             <a:extLst xmlns:a="http://schemas.openxmlformats.org/drawingml/2006/main">
               <a:ext uri="{FF2B5EF4-FFF2-40B4-BE49-F238E27FC236}">
-                <a16:creationId xmlns:a16="http://schemas.microsoft.com/office/drawing/2014/main" id="{E9BCD14D-BC15-4837-B192-5FED46924ADD}"/>
+                <a16:creationId xmlns:a16="http://schemas.microsoft.com/office/drawing/2014/main" id="{F9AD8DE8-2B80-47E7-9527-CE47491DB444}"/>
               </a:ext>
             </a:extLst>
           </p:cNvPr>
@@ -8882,7 +8882,7 @@
           <p:cNvPr id="236" name="Task-Specific Harness-marker-22">
             <a:extLst xmlns:a="http://schemas.openxmlformats.org/drawingml/2006/main">
               <a:ext uri="{FF2B5EF4-FFF2-40B4-BE49-F238E27FC236}">
-                <a16:creationId xmlns:a16="http://schemas.microsoft.com/office/drawing/2014/main" id="{79920AA7-8193-4CBB-9EF2-D00234A91FA3}"/>
+                <a16:creationId xmlns:a16="http://schemas.microsoft.com/office/drawing/2014/main" id="{47E54C6D-C34C-4747-9294-AF3913FD266D}"/>
               </a:ext>
             </a:extLst>
           </p:cNvPr>
@@ -8915,7 +8915,7 @@
           <p:cNvPr id="237" name="Task-Specific Harness-marker-23">
             <a:extLst xmlns:a="http://schemas.openxmlformats.org/drawingml/2006/main">
               <a:ext uri="{FF2B5EF4-FFF2-40B4-BE49-F238E27FC236}">
-                <a16:creationId xmlns:a16="http://schemas.microsoft.com/office/drawing/2014/main" id="{BD0D4B28-D811-43E3-8F2E-E7A97FA5C4D4}"/>
+                <a16:creationId xmlns:a16="http://schemas.microsoft.com/office/drawing/2014/main" id="{630F7538-CB88-4480-A555-7AC07190DF45}"/>
               </a:ext>
             </a:extLst>
           </p:cNvPr>
@@ -8948,7 +8948,7 @@
           <p:cNvPr id="238" name="Task-Specific Harness-marker-24">
             <a:extLst xmlns:a="http://schemas.openxmlformats.org/drawingml/2006/main">
               <a:ext uri="{FF2B5EF4-FFF2-40B4-BE49-F238E27FC236}">
-                <a16:creationId xmlns:a16="http://schemas.microsoft.com/office/drawing/2014/main" id="{72D4C6EB-2C07-4D14-92C2-426D1447704B}"/>
+                <a16:creationId xmlns:a16="http://schemas.microsoft.com/office/drawing/2014/main" id="{BD6A11DA-4521-4F8E-ACB1-52B41653B533}"/>
               </a:ext>
             </a:extLst>
           </p:cNvPr>
@@ -8981,7 +8981,7 @@
           <p:cNvPr id="239" name="Task-Specific Harness-marker-25">
             <a:extLst xmlns:a="http://schemas.openxmlformats.org/drawingml/2006/main">
               <a:ext uri="{FF2B5EF4-FFF2-40B4-BE49-F238E27FC236}">
-                <a16:creationId xmlns:a16="http://schemas.microsoft.com/office/drawing/2014/main" id="{771B1142-C118-420A-85FE-F03772D57D99}"/>
+                <a16:creationId xmlns:a16="http://schemas.microsoft.com/office/drawing/2014/main" id="{9FC41B5D-1B45-491C-9624-3CA1E97FBE4A}"/>
               </a:ext>
             </a:extLst>
           </p:cNvPr>
@@ -9014,7 +9014,7 @@
           <p:cNvPr id="240" name="Task-Specific Harness-marker-26">
             <a:extLst xmlns:a="http://schemas.openxmlformats.org/drawingml/2006/main">
               <a:ext uri="{FF2B5EF4-FFF2-40B4-BE49-F238E27FC236}">
-                <a16:creationId xmlns:a16="http://schemas.microsoft.com/office/drawing/2014/main" id="{7149B88F-3E84-46A5-B2F0-626B1582319E}"/>
+                <a16:creationId xmlns:a16="http://schemas.microsoft.com/office/drawing/2014/main" id="{C6067C76-3757-4767-A275-37EA82327FCB}"/>
               </a:ext>
             </a:extLst>
           </p:cNvPr>
@@ -9047,7 +9047,7 @@
           <p:cNvPr id="241" name="Task-Specific Harness-marker-27">
             <a:extLst xmlns:a="http://schemas.openxmlformats.org/drawingml/2006/main">
               <a:ext uri="{FF2B5EF4-FFF2-40B4-BE49-F238E27FC236}">
-                <a16:creationId xmlns:a16="http://schemas.microsoft.com/office/drawing/2014/main" id="{79943C99-B9A5-47C7-B14C-9FDAA21342B2}"/>
+                <a16:creationId xmlns:a16="http://schemas.microsoft.com/office/drawing/2014/main" id="{7C88EF86-FF12-4623-8CED-E8E2D3D13DD8}"/>
               </a:ext>
             </a:extLst>
           </p:cNvPr>
@@ -9080,7 +9080,7 @@
           <p:cNvPr id="242" name="Task-Specific Harness-marker-28">
             <a:extLst xmlns:a="http://schemas.openxmlformats.org/drawingml/2006/main">
               <a:ext uri="{FF2B5EF4-FFF2-40B4-BE49-F238E27FC236}">
-                <a16:creationId xmlns:a16="http://schemas.microsoft.com/office/drawing/2014/main" id="{6F8B6DDF-F433-4AE5-A419-DD8D18DA4DA0}"/>
+                <a16:creationId xmlns:a16="http://schemas.microsoft.com/office/drawing/2014/main" id="{13FDE0AD-E02B-4E4B-AC78-95958DB362E7}"/>
               </a:ext>
             </a:extLst>
           </p:cNvPr>
@@ -9113,7 +9113,7 @@
           <p:cNvPr id="243" name="Task-Specific Harness-marker-29">
             <a:extLst xmlns:a="http://schemas.openxmlformats.org/drawingml/2006/main">
               <a:ext uri="{FF2B5EF4-FFF2-40B4-BE49-F238E27FC236}">
-                <a16:creationId xmlns:a16="http://schemas.microsoft.com/office/drawing/2014/main" id="{E123081F-AC4D-4E5D-B30E-861DC993E672}"/>
+                <a16:creationId xmlns:a16="http://schemas.microsoft.com/office/drawing/2014/main" id="{2FF2648A-F364-4DB2-8A59-219BFE342771}"/>
               </a:ext>
             </a:extLst>
           </p:cNvPr>
@@ -9146,7 +9146,7 @@
           <p:cNvPr id="244" name="legend-line-LLM-side">
             <a:extLst xmlns:a="http://schemas.openxmlformats.org/drawingml/2006/main">
               <a:ext uri="{FF2B5EF4-FFF2-40B4-BE49-F238E27FC236}">
-                <a16:creationId xmlns:a16="http://schemas.microsoft.com/office/drawing/2014/main" id="{7B5C652A-4A55-4C52-B6A1-EEC09DF9AFFC}"/>
+                <a16:creationId xmlns:a16="http://schemas.microsoft.com/office/drawing/2014/main" id="{5DAC86E9-588D-4219-AEB6-6B216B333972}"/>
               </a:ext>
             </a:extLst>
           </p:cNvPr>
@@ -9177,7 +9177,7 @@
           <p:cNvPr id="245" name="legend-text-LLM-side">
             <a:extLst xmlns:a="http://schemas.openxmlformats.org/drawingml/2006/main">
               <a:ext uri="{FF2B5EF4-FFF2-40B4-BE49-F238E27FC236}">
-                <a16:creationId xmlns:a16="http://schemas.microsoft.com/office/drawing/2014/main" id="{26EFBDA6-8FB2-48AE-A953-B2C5362EE2A4}"/>
+                <a16:creationId xmlns:a16="http://schemas.microsoft.com/office/drawing/2014/main" id="{33C8FCB3-B049-49F4-911F-449F5FFE5ADF}"/>
               </a:ext>
             </a:extLst>
           </p:cNvPr>
@@ -9233,7 +9233,7 @@
           <p:cNvPr id="246" name="legend-line-General Harness">
             <a:extLst xmlns:a="http://schemas.openxmlformats.org/drawingml/2006/main">
               <a:ext uri="{FF2B5EF4-FFF2-40B4-BE49-F238E27FC236}">
-                <a16:creationId xmlns:a16="http://schemas.microsoft.com/office/drawing/2014/main" id="{C34B57FF-C44F-42E2-B76B-79B68D08E712}"/>
+                <a16:creationId xmlns:a16="http://schemas.microsoft.com/office/drawing/2014/main" id="{66DDA9A4-29A7-4D82-8D8C-E524E1BD3303}"/>
               </a:ext>
             </a:extLst>
           </p:cNvPr>
@@ -9264,7 +9264,7 @@
           <p:cNvPr id="247" name="legend-text-General Harness">
             <a:extLst xmlns:a="http://schemas.openxmlformats.org/drawingml/2006/main">
               <a:ext uri="{FF2B5EF4-FFF2-40B4-BE49-F238E27FC236}">
-                <a16:creationId xmlns:a16="http://schemas.microsoft.com/office/drawing/2014/main" id="{DED79C0D-D2C5-4141-A9F2-814EFF40380E}"/>
+                <a16:creationId xmlns:a16="http://schemas.microsoft.com/office/drawing/2014/main" id="{CA549405-2D2A-4942-8895-D402229409F9}"/>
               </a:ext>
             </a:extLst>
           </p:cNvPr>
@@ -9320,7 +9320,7 @@
           <p:cNvPr id="248" name="legend-line-General Time-Series Harness">
             <a:extLst xmlns:a="http://schemas.openxmlformats.org/drawingml/2006/main">
               <a:ext uri="{FF2B5EF4-FFF2-40B4-BE49-F238E27FC236}">
-                <a16:creationId xmlns:a16="http://schemas.microsoft.com/office/drawing/2014/main" id="{CD7B3763-C66E-4AB6-896D-24BF399EB60B}"/>
+                <a16:creationId xmlns:a16="http://schemas.microsoft.com/office/drawing/2014/main" id="{0ABBE7D4-4C4B-428B-9EAA-4C66BDEAA43E}"/>
               </a:ext>
             </a:extLst>
           </p:cNvPr>
@@ -9351,7 +9351,7 @@
           <p:cNvPr id="249" name="legend-text-General Time-Series Harness">
             <a:extLst xmlns:a="http://schemas.openxmlformats.org/drawingml/2006/main">
               <a:ext uri="{FF2B5EF4-FFF2-40B4-BE49-F238E27FC236}">
-                <a16:creationId xmlns:a16="http://schemas.microsoft.com/office/drawing/2014/main" id="{275ACFB1-14F5-4505-A873-EFDDFFA5E180}"/>
+                <a16:creationId xmlns:a16="http://schemas.microsoft.com/office/drawing/2014/main" id="{2A835F24-0940-4DC2-9322-43BF913723F6}"/>
               </a:ext>
             </a:extLst>
           </p:cNvPr>
@@ -9407,7 +9407,7 @@
           <p:cNvPr id="250" name="legend-line-Task-Specific Harness">
             <a:extLst xmlns:a="http://schemas.openxmlformats.org/drawingml/2006/main">
               <a:ext uri="{FF2B5EF4-FFF2-40B4-BE49-F238E27FC236}">
-                <a16:creationId xmlns:a16="http://schemas.microsoft.com/office/drawing/2014/main" id="{0C23DDFE-AEFB-4ED0-B639-EE5C1B3C2A04}"/>
+                <a16:creationId xmlns:a16="http://schemas.microsoft.com/office/drawing/2014/main" id="{507A7F04-78E5-4CF3-90C1-BFD84179FA01}"/>
               </a:ext>
             </a:extLst>
           </p:cNvPr>
@@ -9438,7 +9438,7 @@
           <p:cNvPr id="251" name="legend-text-Task-Specific Harness">
             <a:extLst xmlns:a="http://schemas.openxmlformats.org/drawingml/2006/main">
               <a:ext uri="{FF2B5EF4-FFF2-40B4-BE49-F238E27FC236}">
-                <a16:creationId xmlns:a16="http://schemas.microsoft.com/office/drawing/2014/main" id="{A16BD705-80ED-4AE0-A758-08FFCC5DBF72}"/>
+                <a16:creationId xmlns:a16="http://schemas.microsoft.com/office/drawing/2014/main" id="{00166C2F-C923-474D-9836-6A9D8F862C5E}"/>
               </a:ext>
             </a:extLst>
           </p:cNvPr>
@@ -9494,7 +9494,7 @@
           <p:cNvPr id="252" name="counting-note">
             <a:extLst xmlns:a="http://schemas.openxmlformats.org/drawingml/2006/main">
               <a:ext uri="{FF2B5EF4-FFF2-40B4-BE49-F238E27FC236}">
-                <a16:creationId xmlns:a16="http://schemas.microsoft.com/office/drawing/2014/main" id="{FFC72F2B-5765-4E46-9E9A-DD7DF8145C24}"/>
+                <a16:creationId xmlns:a16="http://schemas.microsoft.com/office/drawing/2014/main" id="{ECCDDD71-4729-4B9C-8481-CFB3DDB882E0}"/>
               </a:ext>
             </a:extLst>
           </p:cNvPr>
@@ -9548,7 +9548,7 @@
     </p:spTree>
     <p:extLst>
       <p:ext uri="{BB962C8B-B14F-4D97-AF65-F5344CB8AC3E}">
-        <p14:creationId xmlns:p14="http://schemas.microsoft.com/office/powerpoint/2010/main" val="966766966"/>
+        <p14:creationId xmlns:p14="http://schemas.microsoft.com/office/powerpoint/2010/main" val="938765962"/>
       </p:ext>
     </p:extLst>
   </p:cSld>

</xml_diff>